<commit_message>
docs: pitch deck v2 — numbers/proof/visual style
Rework the deck toward the jury-preferred style: problem slide with big
stats + cited sources, market slide with current-share framing (~0%),
concrete business-model figures, a 'usage du soutien' slide, and a team
slide with an open role. Real-data blanks marked as orange placeholders.

Co-Authored-By: Claude Opus 4.8 <noreply@anthropic.com>
Claude-Session: https://claude.ai/code/session_01XuNSKfFGFgyRA5WffAv1uC
</commit_message>
<xml_diff>
--- a/scratch/Forgeron_Pitch_Deck.pptx
+++ b/scratch/Forgeron_Pitch_Deck.pptx
@@ -17,9 +17,10 @@
     <p:sldId id="265" r:id="rId11"/>
     <p:sldId id="266" r:id="rId12"/>
     <p:sldId id="267" r:id="rId13"/>
+    <p:sldId id="268" r:id="rId14"/>
   </p:sldIdLst>
   <p:notesMasterIdLst>
-    <p:notesMasterId r:id="rId14"/>
+    <p:notesMasterId r:id="rId15"/>
   </p:notesMasterIdLst>
   <p:sldSz cx="12192000" cy="6858000"/>
   <p:notesSz cx="6858000" cy="12192000"/>
@@ -801,6 +802,94 @@
             <a:fld id="{F7021451-1387-4CA6-816F-3879F97B5CBC}" type="slidenum">
               <a:rPr lang="en-US"/>
               <a:t>12</a:t>
+            </a:fld>
+            <a:endParaRPr lang="en-US"/>
+          </a:p>
+        </p:txBody>
+      </p:sp>
+    </p:spTree>
+    <p:extLst>
+      <p:ext uri="{BB962C8B-B14F-4D97-AF65-F5344CB8AC3E}">
+        <p14:creationId xmlns:p14="http://schemas.microsoft.com/office/powerpoint/2010/main" val="1024086991"/>
+      </p:ext>
+    </p:extLst>
+  </p:cSld>
+  <p:clrMapOvr>
+    <a:masterClrMapping/>
+  </p:clrMapOvr>
+</p:notes>
+</file>
+
+<file path=ppt/notesSlides/notesSlide13.xml><?xml version="1.0" encoding="utf-8"?>
+<p:notes xmlns:a="http://schemas.openxmlformats.org/drawingml/2006/main" xmlns:r="http://schemas.openxmlformats.org/officeDocument/2006/relationships" xmlns:p="http://schemas.openxmlformats.org/presentationml/2006/main">
+  <p:cSld>
+    <p:spTree>
+      <p:nvGrpSpPr>
+        <p:cNvPr id="1" name=""/>
+        <p:cNvGrpSpPr/>
+        <p:nvPr/>
+      </p:nvGrpSpPr>
+      <p:grpSpPr>
+        <a:xfrm>
+          <a:off x="0" y="0"/>
+          <a:ext cx="0" cy="0"/>
+          <a:chOff x="0" y="0"/>
+          <a:chExt cx="0" cy="0"/>
+        </a:xfrm>
+      </p:grpSpPr>
+      <p:sp>
+        <p:nvSpPr>
+          <p:cNvPr id="2" name="Slide Image Placeholder 1"/>
+          <p:cNvSpPr>
+            <a:spLocks noGrp="1" noRot="1" noChangeAspect="1"/>
+          </p:cNvSpPr>
+          <p:nvPr>
+            <p:ph type="sldImg"/>
+          </p:nvPr>
+        </p:nvSpPr>
+        <p:spPr/>
+      </p:sp>
+      <p:sp>
+        <p:nvSpPr>
+          <p:cNvPr id="3" name="Notes Placeholder 2"/>
+          <p:cNvSpPr>
+            <a:spLocks noGrp="1"/>
+          </p:cNvSpPr>
+          <p:nvPr>
+            <p:ph type="body" idx="1"/>
+          </p:nvPr>
+        </p:nvSpPr>
+        <p:spPr/>
+        <p:txBody>
+          <a:bodyPr/>
+          <a:lstStyle/>
+          <a:p>
+            <a:r>
+              <a:rPr lang="en-US" dirty="0"/>
+              <a:t/>
+            </a:r>
+            <a:endParaRPr lang="en-US" dirty="0"/>
+          </a:p>
+        </p:txBody>
+      </p:sp>
+      <p:sp>
+        <p:nvSpPr>
+          <p:cNvPr id="4" name="Slide Number Placeholder 3"/>
+          <p:cNvSpPr>
+            <a:spLocks noGrp="1"/>
+          </p:cNvSpPr>
+          <p:nvPr>
+            <p:ph type="sldNum" sz="quarter" idx="10"/>
+          </p:nvPr>
+        </p:nvSpPr>
+        <p:spPr/>
+        <p:txBody>
+          <a:bodyPr/>
+          <a:lstStyle/>
+          <a:p>
+            <a:fld id="{F7021451-1387-4CA6-816F-3879F97B5CBC}" type="slidenum">
+              <a:rPr lang="en-US"/>
+              <a:t>13</a:t>
             </a:fld>
             <a:endParaRPr lang="en-US"/>
           </a:p>
@@ -2255,7 +2344,7 @@
         <p:spPr>
           <a:xfrm>
             <a:off x="566928" y="1371600"/>
-            <a:ext cx="2834640" cy="4023360"/>
+            <a:ext cx="2743200" cy="3291840"/>
           </a:xfrm>
           <a:prstGeom prst="rect">
             <a:avLst/>
@@ -2270,8 +2359,8 @@
         </p:nvSpPr>
         <p:spPr>
           <a:xfrm>
-            <a:off x="566928" y="5440680"/>
-            <a:ext cx="2834640" cy="274320"/>
+            <a:off x="566928" y="4709160"/>
+            <a:ext cx="2743200" cy="274320"/>
           </a:xfrm>
           <a:prstGeom prst="rect">
             <a:avLst/>
@@ -2309,12 +2398,222 @@
         </p:nvSpPr>
         <p:spPr>
           <a:xfrm>
-            <a:off x="3840480" y="1371600"/>
-            <a:ext cx="7781544" cy="2788920"/>
+            <a:off x="3566160" y="1371600"/>
+            <a:ext cx="3845052" cy="1051560"/>
           </a:xfrm>
           <a:prstGeom prst="roundRect">
             <a:avLst>
-              <a:gd name="adj" fmla="val 2951"/>
+              <a:gd name="adj" fmla="val 7826"/>
+            </a:avLst>
+          </a:prstGeom>
+          <a:solidFill>
+            <a:srgbClr val="2B3644"/>
+          </a:solidFill>
+          <a:ln w="12700">
+            <a:solidFill>
+              <a:srgbClr val="2B3644"/>
+            </a:solidFill>
+            <a:prstDash val="solid"/>
+          </a:ln>
+        </p:spPr>
+      </p:sp>
+      <p:sp>
+        <p:nvSpPr>
+          <p:cNvPr id="7" name="Text 4"/>
+          <p:cNvSpPr txBox="1"/>
+          <p:nvPr/>
+        </p:nvSpPr>
+        <p:spPr>
+          <a:xfrm>
+            <a:off x="3566160" y="1481328"/>
+            <a:ext cx="3845052" cy="502920"/>
+          </a:xfrm>
+          <a:prstGeom prst="rect">
+            <a:avLst/>
+          </a:prstGeom>
+          <a:noFill/>
+          <a:ln/>
+        </p:spPr>
+        <p:txBody>
+          <a:bodyPr wrap="square" lIns="0" tIns="0" rIns="0" bIns="0" rtlCol="0" anchor="ctr"/>
+          <a:lstStyle/>
+          <a:p>
+            <a:pPr algn="ctr" indent="0" marL="0">
+              <a:buNone/>
+            </a:pPr>
+            <a:r>
+              <a:rPr lang="en-US" sz="2000" b="1" dirty="0">
+                <a:solidFill>
+                  <a:srgbClr val="FFB347"/>
+                </a:solidFill>
+                <a:latin typeface="Calibri" pitchFamily="34" charset="0"/>
+                <a:ea typeface="Calibri" pitchFamily="34" charset="-122"/>
+                <a:cs typeface="Calibri" pitchFamily="34" charset="-120"/>
+              </a:rPr>
+              <a:t>⟦ ___ FCFA ⟧</a:t>
+            </a:r>
+            <a:endParaRPr lang="en-US" sz="2000" dirty="0"/>
+          </a:p>
+        </p:txBody>
+      </p:sp>
+      <p:sp>
+        <p:nvSpPr>
+          <p:cNvPr id="8" name="Text 5"/>
+          <p:cNvSpPr txBox="1"/>
+          <p:nvPr/>
+        </p:nvSpPr>
+        <p:spPr>
+          <a:xfrm>
+            <a:off x="3566160" y="1965960"/>
+            <a:ext cx="3845052" cy="365760"/>
+          </a:xfrm>
+          <a:prstGeom prst="rect">
+            <a:avLst/>
+          </a:prstGeom>
+          <a:noFill/>
+          <a:ln/>
+        </p:spPr>
+        <p:txBody>
+          <a:bodyPr wrap="square" lIns="0" tIns="0" rIns="0" bIns="0" rtlCol="0" anchor="ctr"/>
+          <a:lstStyle/>
+          <a:p>
+            <a:pPr algn="ctr" indent="0" marL="0">
+              <a:buNone/>
+            </a:pPr>
+            <a:r>
+              <a:rPr lang="en-US" sz="1100" dirty="0">
+                <a:solidFill>
+                  <a:srgbClr val="9AA6B2"/>
+                </a:solidFill>
+                <a:latin typeface="Calibri" pitchFamily="34" charset="0"/>
+                <a:ea typeface="Calibri" pitchFamily="34" charset="-122"/>
+                <a:cs typeface="Calibri" pitchFamily="34" charset="-120"/>
+              </a:rPr>
+              <a:t>coût de construction de la machine</a:t>
+            </a:r>
+            <a:endParaRPr lang="en-US" sz="1100" dirty="0"/>
+          </a:p>
+        </p:txBody>
+      </p:sp>
+      <p:sp>
+        <p:nvSpPr>
+          <p:cNvPr id="9" name="Shape 6"/>
+          <p:cNvSpPr/>
+          <p:nvPr/>
+        </p:nvSpPr>
+        <p:spPr>
+          <a:xfrm>
+            <a:off x="7776972" y="1371600"/>
+            <a:ext cx="3845052" cy="1051560"/>
+          </a:xfrm>
+          <a:prstGeom prst="roundRect">
+            <a:avLst>
+              <a:gd name="adj" fmla="val 7826"/>
+            </a:avLst>
+          </a:prstGeom>
+          <a:solidFill>
+            <a:srgbClr val="2B3644"/>
+          </a:solidFill>
+          <a:ln w="12700">
+            <a:solidFill>
+              <a:srgbClr val="2B3644"/>
+            </a:solidFill>
+            <a:prstDash val="solid"/>
+          </a:ln>
+        </p:spPr>
+      </p:sp>
+      <p:sp>
+        <p:nvSpPr>
+          <p:cNvPr id="10" name="Text 7"/>
+          <p:cNvSpPr txBox="1"/>
+          <p:nvPr/>
+        </p:nvSpPr>
+        <p:spPr>
+          <a:xfrm>
+            <a:off x="7776972" y="1481328"/>
+            <a:ext cx="3845052" cy="502920"/>
+          </a:xfrm>
+          <a:prstGeom prst="rect">
+            <a:avLst/>
+          </a:prstGeom>
+          <a:noFill/>
+          <a:ln/>
+        </p:spPr>
+        <p:txBody>
+          <a:bodyPr wrap="square" lIns="0" tIns="0" rIns="0" bIns="0" rtlCol="0" anchor="ctr"/>
+          <a:lstStyle/>
+          <a:p>
+            <a:pPr algn="ctr" indent="0" marL="0">
+              <a:buNone/>
+            </a:pPr>
+            <a:r>
+              <a:rPr lang="en-US" sz="2000" b="1" dirty="0">
+                <a:solidFill>
+                  <a:srgbClr val="FFB347"/>
+                </a:solidFill>
+                <a:latin typeface="Calibri" pitchFamily="34" charset="0"/>
+                <a:ea typeface="Calibri" pitchFamily="34" charset="-122"/>
+                <a:cs typeface="Calibri" pitchFamily="34" charset="-120"/>
+              </a:rPr>
+              <a:t>⟦ ± __ mm ⟧</a:t>
+            </a:r>
+            <a:endParaRPr lang="en-US" sz="2000" dirty="0"/>
+          </a:p>
+        </p:txBody>
+      </p:sp>
+      <p:sp>
+        <p:nvSpPr>
+          <p:cNvPr id="11" name="Text 8"/>
+          <p:cNvSpPr txBox="1"/>
+          <p:nvPr/>
+        </p:nvSpPr>
+        <p:spPr>
+          <a:xfrm>
+            <a:off x="7776972" y="1965960"/>
+            <a:ext cx="3845052" cy="365760"/>
+          </a:xfrm>
+          <a:prstGeom prst="rect">
+            <a:avLst/>
+          </a:prstGeom>
+          <a:noFill/>
+          <a:ln/>
+        </p:spPr>
+        <p:txBody>
+          <a:bodyPr wrap="square" lIns="0" tIns="0" rIns="0" bIns="0" rtlCol="0" anchor="ctr"/>
+          <a:lstStyle/>
+          <a:p>
+            <a:pPr algn="ctr" indent="0" marL="0">
+              <a:buNone/>
+            </a:pPr>
+            <a:r>
+              <a:rPr lang="en-US" sz="1100" dirty="0">
+                <a:solidFill>
+                  <a:srgbClr val="9AA6B2"/>
+                </a:solidFill>
+                <a:latin typeface="Calibri" pitchFamily="34" charset="0"/>
+                <a:ea typeface="Calibri" pitchFamily="34" charset="-122"/>
+                <a:cs typeface="Calibri" pitchFamily="34" charset="-120"/>
+              </a:rPr>
+              <a:t>précision / tolérance atteinte</a:t>
+            </a:r>
+            <a:endParaRPr lang="en-US" sz="1100" dirty="0"/>
+          </a:p>
+        </p:txBody>
+      </p:sp>
+      <p:sp>
+        <p:nvSpPr>
+          <p:cNvPr id="12" name="Shape 9"/>
+          <p:cNvSpPr/>
+          <p:nvPr/>
+        </p:nvSpPr>
+        <p:spPr>
+          <a:xfrm>
+            <a:off x="3566160" y="2560320"/>
+            <a:ext cx="8055864" cy="1874520"/>
+          </a:xfrm>
+          <a:prstGeom prst="roundRect">
+            <a:avLst>
+              <a:gd name="adj" fmla="val 4390"/>
             </a:avLst>
           </a:prstGeom>
           <a:solidFill>
@@ -2330,13 +2629,13 @@
       </p:sp>
       <p:sp>
         <p:nvSpPr>
-          <p:cNvPr id="7" name="Text 4"/>
-          <p:cNvSpPr txBox="1"/>
-          <p:nvPr/>
-        </p:nvSpPr>
-        <p:spPr>
-          <a:xfrm>
-            <a:off x="4069080" y="1536192"/>
+          <p:cNvPr id="13" name="Text 10"/>
+          <p:cNvSpPr txBox="1"/>
+          <p:nvPr/>
+        </p:nvSpPr>
+        <p:spPr>
+          <a:xfrm>
+            <a:off x="3794760" y="2697480"/>
             <a:ext cx="5486400" cy="320040"/>
           </a:xfrm>
           <a:prstGeom prst="rect">
@@ -2369,14 +2668,14 @@
       </p:sp>
       <p:sp>
         <p:nvSpPr>
-          <p:cNvPr id="8" name="Text 5"/>
-          <p:cNvSpPr txBox="1"/>
-          <p:nvPr/>
-        </p:nvSpPr>
-        <p:spPr>
-          <a:xfrm>
-            <a:off x="4114800" y="1920240"/>
-            <a:ext cx="7232904" cy="2148840"/>
+          <p:cNvPr id="14" name="Text 11"/>
+          <p:cNvSpPr txBox="1"/>
+          <p:nvPr/>
+        </p:nvSpPr>
+        <p:spPr>
+          <a:xfrm>
+            <a:off x="3840480" y="3063240"/>
+            <a:ext cx="7507224" cy="1280160"/>
           </a:xfrm>
           <a:prstGeom prst="rect">
             <a:avLst/>
@@ -2390,13 +2689,13 @@
           <a:p>
             <a:pPr marL="342900" indent="-342900">
               <a:spcAft>
-                <a:spcPts val="600"/>
+                <a:spcPts val="500"/>
               </a:spcAft>
               <a:buSzPct val="100000"/>
               <a:buChar char="✓"/>
             </a:pPr>
             <a:r>
-              <a:rPr lang="en-US" sz="1350" dirty="0">
+              <a:rPr lang="en-US" sz="1300" dirty="0">
                 <a:solidFill>
                   <a:srgbClr val="EAECEF"/>
                 </a:solidFill>
@@ -2406,18 +2705,18 @@
               </a:rPr>
               <a:t>Machine 5-axes physique construite &amp; fonctionnelle</a:t>
             </a:r>
-            <a:endParaRPr lang="en-US" sz="1350" dirty="0"/>
+            <a:endParaRPr lang="en-US" sz="1300" dirty="0"/>
           </a:p>
           <a:p>
             <a:pPr marL="342900" indent="-342900">
               <a:spcAft>
-                <a:spcPts val="600"/>
+                <a:spcPts val="500"/>
               </a:spcAft>
               <a:buSzPct val="100000"/>
               <a:buChar char="✓"/>
             </a:pPr>
             <a:r>
-              <a:rPr lang="en-US" sz="1350" dirty="0">
+              <a:rPr lang="en-US" sz="1300" dirty="0">
                 <a:solidFill>
                   <a:srgbClr val="EAECEF"/>
                 </a:solidFill>
@@ -2427,18 +2726,18 @@
               </a:rPr>
               <a:t>App de contrôle + agent IA opérationnels</a:t>
             </a:r>
-            <a:endParaRPr lang="en-US" sz="1350" dirty="0"/>
+            <a:endParaRPr lang="en-US" sz="1300" dirty="0"/>
           </a:p>
           <a:p>
             <a:pPr marL="342900" indent="-342900">
               <a:spcAft>
-                <a:spcPts val="600"/>
+                <a:spcPts val="500"/>
               </a:spcAft>
               <a:buSzPct val="100000"/>
               <a:buChar char="✓"/>
             </a:pPr>
             <a:r>
-              <a:rPr lang="en-US" sz="1350" dirty="0">
+              <a:rPr lang="en-US" sz="1300" dirty="0">
                 <a:solidFill>
                   <a:srgbClr val="EAECEF"/>
                 </a:solidFill>
@@ -2446,20 +2745,20 @@
                 <a:ea typeface="Calibri" pitchFamily="34" charset="-122"/>
                 <a:cs typeface="Calibri" pitchFamily="34" charset="-120"/>
               </a:rPr>
-              <a:t>Vidéo de démonstration publiée</a:t>
-            </a:r>
-            <a:endParaRPr lang="en-US" sz="1350" dirty="0"/>
+              <a:t>Vidéo de démonstration + code open-source (GitHub)</a:t>
+            </a:r>
+            <a:endParaRPr lang="en-US" sz="1300" dirty="0"/>
           </a:p>
           <a:p>
             <a:pPr marL="342900" indent="-342900">
               <a:spcAft>
-                <a:spcPts val="600"/>
+                <a:spcPts val="500"/>
               </a:spcAft>
               <a:buSzPct val="100000"/>
               <a:buChar char="✓"/>
             </a:pPr>
             <a:r>
-              <a:rPr lang="en-US" sz="1350" dirty="0">
+              <a:rPr lang="en-US" sz="1300" dirty="0">
                 <a:solidFill>
                   <a:srgbClr val="EAECEF"/>
                 </a:solidFill>
@@ -2467,20 +2766,20 @@
                 <a:ea typeface="Calibri" pitchFamily="34" charset="-122"/>
                 <a:cs typeface="Calibri" pitchFamily="34" charset="-120"/>
               </a:rPr>
-              <a:t>Code open-source (GitHub)</a:t>
-            </a:r>
-            <a:endParaRPr lang="en-US" sz="1350" dirty="0"/>
+              <a:t>Partenaire intéressé : Kouratechnique ⟦ besoin : __ machines ⟧</a:t>
+            </a:r>
+            <a:endParaRPr lang="en-US" sz="1300" dirty="0"/>
           </a:p>
           <a:p>
             <a:pPr marL="342900" indent="-342900">
               <a:spcAft>
-                <a:spcPts val="600"/>
+                <a:spcPts val="500"/>
               </a:spcAft>
               <a:buSzPct val="100000"/>
               <a:buChar char="✓"/>
             </a:pPr>
             <a:r>
-              <a:rPr lang="en-US" sz="1350" dirty="0">
+              <a:rPr lang="en-US" sz="1300" dirty="0">
                 <a:solidFill>
                   <a:srgbClr val="EAECEF"/>
                 </a:solidFill>
@@ -2488,47 +2787,26 @@
                 <a:ea typeface="Calibri" pitchFamily="34" charset="-122"/>
                 <a:cs typeface="Calibri" pitchFamily="34" charset="-120"/>
               </a:rPr>
-              <a:t>1er partenaire intéressé : Kouratechnique</a:t>
-            </a:r>
-            <a:endParaRPr lang="en-US" sz="1350" dirty="0"/>
-          </a:p>
-          <a:p>
-            <a:pPr marL="342900" indent="-342900">
-              <a:spcAft>
-                <a:spcPts val="600"/>
-              </a:spcAft>
-              <a:buSzPct val="100000"/>
-              <a:buChar char="✓"/>
-            </a:pPr>
-            <a:r>
-              <a:rPr lang="en-US" sz="1350" dirty="0">
-                <a:solidFill>
-                  <a:srgbClr val="EAECEF"/>
-                </a:solidFill>
-                <a:latin typeface="Calibri" pitchFamily="34" charset="0"/>
-                <a:ea typeface="Calibri" pitchFamily="34" charset="-122"/>
-                <a:cs typeface="Calibri" pitchFamily="34" charset="-120"/>
-              </a:rPr>
               <a:t>Équipe de 2 (ingénieur + technicien)</a:t>
             </a:r>
-            <a:endParaRPr lang="en-US" sz="1350" dirty="0"/>
-          </a:p>
-        </p:txBody>
-      </p:sp>
-      <p:sp>
-        <p:nvSpPr>
-          <p:cNvPr id="9" name="Shape 6"/>
+            <a:endParaRPr lang="en-US" sz="1300" dirty="0"/>
+          </a:p>
+        </p:txBody>
+      </p:sp>
+      <p:sp>
+        <p:nvSpPr>
+          <p:cNvPr id="15" name="Shape 12"/>
           <p:cNvSpPr/>
           <p:nvPr/>
         </p:nvSpPr>
         <p:spPr>
           <a:xfrm>
-            <a:off x="3840480" y="4343400"/>
-            <a:ext cx="7781544" cy="1097280"/>
+            <a:off x="3566160" y="4526280"/>
+            <a:ext cx="8055864" cy="868680"/>
           </a:xfrm>
           <a:prstGeom prst="roundRect">
             <a:avLst>
-              <a:gd name="adj" fmla="val 7500"/>
+              <a:gd name="adj" fmla="val 9474"/>
             </a:avLst>
           </a:prstGeom>
           <a:solidFill>
@@ -2544,14 +2822,14 @@
       </p:sp>
       <p:sp>
         <p:nvSpPr>
-          <p:cNvPr id="10" name="Text 7"/>
-          <p:cNvSpPr txBox="1"/>
-          <p:nvPr/>
-        </p:nvSpPr>
-        <p:spPr>
-          <a:xfrm>
-            <a:off x="4069080" y="4343400"/>
-            <a:ext cx="7324344" cy="1097280"/>
+          <p:cNvPr id="16" name="Text 13"/>
+          <p:cNvSpPr txBox="1"/>
+          <p:nvPr/>
+        </p:nvSpPr>
+        <p:spPr>
+          <a:xfrm>
+            <a:off x="3794760" y="4526280"/>
+            <a:ext cx="7598664" cy="868680"/>
           </a:xfrm>
           <a:prstGeom prst="rect">
             <a:avLst/>
@@ -2567,7 +2845,7 @@
               <a:buNone/>
             </a:pPr>
             <a:r>
-              <a:rPr lang="en-US" sz="1350" b="1" dirty="0">
+              <a:rPr lang="en-US" sz="1300" b="1" dirty="0">
                 <a:solidFill>
                   <a:srgbClr val="FFB347"/>
                 </a:solidFill>
@@ -2581,7 +2859,7 @@
               <a:buNone/>
             </a:pPr>
             <a:r>
-              <a:rPr lang="en-US" sz="1350" dirty="0">
+              <a:rPr lang="en-US" sz="1300" dirty="0">
                 <a:solidFill>
                   <a:srgbClr val="EAECEF"/>
                 </a:solidFill>
@@ -2589,21 +2867,21 @@
                 <a:ea typeface="Calibri" pitchFamily="34" charset="-122"/>
                 <a:cs typeface="Calibri" pitchFamily="34" charset="-120"/>
               </a:rPr>
-              <a:t>pilotes clients réels · durcissement &amp; edge de l'agent IA · lettre de partenariat.</a:t>
-            </a:r>
-            <a:endParaRPr lang="en-US" sz="1350" dirty="0"/>
-          </a:p>
-        </p:txBody>
-      </p:sp>
-      <p:sp>
-        <p:nvSpPr>
-          <p:cNvPr id="11" name="Text 8"/>
-          <p:cNvSpPr txBox="1"/>
-          <p:nvPr/>
-        </p:nvSpPr>
-        <p:spPr>
-          <a:xfrm>
-            <a:off x="566928" y="6455664"/>
+              <a:t>pilotes clients réels · durcissement &amp; edge de l'agent IA · lettre de partenariat Kouratechnique.</a:t>
+            </a:r>
+            <a:endParaRPr lang="en-US" sz="1300" dirty="0"/>
+          </a:p>
+        </p:txBody>
+      </p:sp>
+      <p:sp>
+        <p:nvSpPr>
+          <p:cNvPr id="17" name="Text 14"/>
+          <p:cNvSpPr txBox="1"/>
+          <p:nvPr/>
+        </p:nvSpPr>
+        <p:spPr>
+          <a:xfrm>
+            <a:off x="566928" y="6473952"/>
             <a:ext cx="11055096" cy="274320"/>
           </a:xfrm>
           <a:prstGeom prst="rect">
@@ -2616,7 +2894,7 @@
           <a:bodyPr wrap="square" lIns="0" tIns="0" rIns="0" bIns="0" rtlCol="0" anchor="ctr"/>
           <a:lstStyle/>
           <a:p>
-            <a:pPr algn="l" indent="0" marL="0">
+            <a:pPr indent="0" marL="0">
               <a:buNone/>
             </a:pPr>
             <a:r>
@@ -2742,7 +3020,7 @@
                 <a:ea typeface="Calibri" pitchFamily="34" charset="-122"/>
                 <a:cs typeface="Calibri" pitchFamily="34" charset="-120"/>
               </a:rPr>
-              <a:t>L'équipe</a:t>
+              <a:t>Usage du soutien</a:t>
             </a:r>
             <a:endParaRPr lang="en-US" sz="2800" dirty="0"/>
           </a:p>
@@ -2756,12 +3034,12 @@
         </p:nvSpPr>
         <p:spPr>
           <a:xfrm>
-            <a:off x="566928" y="1554480"/>
-            <a:ext cx="5253228" cy="3108960"/>
+            <a:off x="566928" y="1417320"/>
+            <a:ext cx="3502152" cy="2194560"/>
           </a:xfrm>
           <a:prstGeom prst="roundRect">
             <a:avLst>
-              <a:gd name="adj" fmla="val 2647"/>
+              <a:gd name="adj" fmla="val 3750"/>
             </a:avLst>
           </a:prstGeom>
           <a:solidFill>
@@ -2777,23 +3055,46 @@
       </p:sp>
       <p:sp>
         <p:nvSpPr>
-          <p:cNvPr id="5" name="Shape 3"/>
-          <p:cNvSpPr/>
-          <p:nvPr/>
-        </p:nvSpPr>
-        <p:spPr>
-          <a:xfrm>
-            <a:off x="2690622" y="1828800"/>
-            <a:ext cx="1005840" cy="1005840"/>
-          </a:xfrm>
-          <a:prstGeom prst="ellipse">
-            <a:avLst/>
+          <p:cNvPr id="5" name="Text 3"/>
+          <p:cNvSpPr txBox="1"/>
+          <p:nvPr/>
+        </p:nvSpPr>
+        <p:spPr>
+          <a:xfrm>
+            <a:off x="795528" y="1645920"/>
+            <a:ext cx="457200" cy="457200"/>
+          </a:xfrm>
+          <a:prstGeom prst="roundRect">
+            <a:avLst>
+              <a:gd name="adj" fmla="val 14000"/>
+            </a:avLst>
           </a:prstGeom>
           <a:solidFill>
             <a:srgbClr val="FF6A1A"/>
           </a:solidFill>
           <a:ln/>
         </p:spPr>
+        <p:txBody>
+          <a:bodyPr wrap="square" lIns="0" tIns="0" rIns="0" bIns="0" rtlCol="0" anchor="ctr"/>
+          <a:lstStyle/>
+          <a:p>
+            <a:pPr algn="ctr" indent="0" marL="0">
+              <a:buNone/>
+            </a:pPr>
+            <a:r>
+              <a:rPr lang="en-US" sz="1600" b="1" dirty="0">
+                <a:solidFill>
+                  <a:srgbClr val="FFFFFF"/>
+                </a:solidFill>
+                <a:latin typeface="Calibri" pitchFamily="34" charset="0"/>
+                <a:ea typeface="Calibri" pitchFamily="34" charset="-122"/>
+                <a:cs typeface="Calibri" pitchFamily="34" charset="-120"/>
+              </a:rPr>
+              <a:t>1</a:t>
+            </a:r>
+            <a:endParaRPr lang="en-US" sz="1600" dirty="0"/>
+          </a:p>
+        </p:txBody>
       </p:sp>
       <p:sp>
         <p:nvSpPr>
@@ -2803,8 +3104,8 @@
         </p:nvSpPr>
         <p:spPr>
           <a:xfrm>
-            <a:off x="2690622" y="1828800"/>
-            <a:ext cx="1005840" cy="1005840"/>
+            <a:off x="795528" y="2240280"/>
+            <a:ext cx="3044952" cy="457200"/>
           </a:xfrm>
           <a:prstGeom prst="rect">
             <a:avLst/>
@@ -2816,11 +3117,11 @@
           <a:bodyPr wrap="square" lIns="0" tIns="0" rIns="0" bIns="0" rtlCol="0" anchor="ctr"/>
           <a:lstStyle/>
           <a:p>
-            <a:pPr algn="ctr" indent="0" marL="0">
-              <a:buNone/>
-            </a:pPr>
-            <a:r>
-              <a:rPr lang="en-US" sz="2400" b="1" dirty="0">
+            <a:pPr indent="0" marL="0">
+              <a:buNone/>
+            </a:pPr>
+            <a:r>
+              <a:rPr lang="en-US" sz="1600" b="1" dirty="0">
                 <a:solidFill>
                   <a:srgbClr val="FFFFFF"/>
                 </a:solidFill>
@@ -2828,9 +3129,9 @@
                 <a:ea typeface="Calibri" pitchFamily="34" charset="-122"/>
                 <a:cs typeface="Calibri" pitchFamily="34" charset="-120"/>
               </a:rPr>
-              <a:t>LS</a:t>
-            </a:r>
-            <a:endParaRPr lang="en-US" sz="2400" dirty="0"/>
+              <a:t>Skilling IA</a:t>
+            </a:r>
+            <a:endParaRPr lang="en-US" sz="1600" dirty="0"/>
           </a:p>
         </p:txBody>
       </p:sp>
@@ -2842,86 +3143,8 @@
         </p:nvSpPr>
         <p:spPr>
           <a:xfrm>
-            <a:off x="749808" y="2971800"/>
-            <a:ext cx="4887468" cy="411480"/>
-          </a:xfrm>
-          <a:prstGeom prst="rect">
-            <a:avLst/>
-          </a:prstGeom>
-          <a:noFill/>
-          <a:ln/>
-        </p:spPr>
-        <p:txBody>
-          <a:bodyPr wrap="square" lIns="0" tIns="0" rIns="0" bIns="0" rtlCol="0" anchor="ctr"/>
-          <a:lstStyle/>
-          <a:p>
-            <a:pPr algn="ctr" indent="0" marL="0">
-              <a:buNone/>
-            </a:pPr>
-            <a:r>
-              <a:rPr lang="en-US" sz="1800" b="1" dirty="0">
-                <a:solidFill>
-                  <a:srgbClr val="FFFFFF"/>
-                </a:solidFill>
-                <a:latin typeface="Calibri" pitchFamily="34" charset="0"/>
-                <a:ea typeface="Calibri" pitchFamily="34" charset="-122"/>
-                <a:cs typeface="Calibri" pitchFamily="34" charset="-120"/>
-              </a:rPr>
-              <a:t>Lamine SACKO</a:t>
-            </a:r>
-            <a:endParaRPr lang="en-US" sz="1800" dirty="0"/>
-          </a:p>
-        </p:txBody>
-      </p:sp>
-      <p:sp>
-        <p:nvSpPr>
-          <p:cNvPr id="8" name="Text 6"/>
-          <p:cNvSpPr txBox="1"/>
-          <p:nvPr/>
-        </p:nvSpPr>
-        <p:spPr>
-          <a:xfrm>
-            <a:off x="749808" y="3383280"/>
-            <a:ext cx="4887468" cy="320040"/>
-          </a:xfrm>
-          <a:prstGeom prst="rect">
-            <a:avLst/>
-          </a:prstGeom>
-          <a:noFill/>
-          <a:ln/>
-        </p:spPr>
-        <p:txBody>
-          <a:bodyPr wrap="square" lIns="0" tIns="0" rIns="0" bIns="0" rtlCol="0" anchor="ctr"/>
-          <a:lstStyle/>
-          <a:p>
-            <a:pPr algn="ctr" indent="0" marL="0">
-              <a:buNone/>
-            </a:pPr>
-            <a:r>
-              <a:rPr lang="en-US" sz="1300" b="1" dirty="0">
-                <a:solidFill>
-                  <a:srgbClr val="FF6A1A"/>
-                </a:solidFill>
-                <a:latin typeface="Calibri" pitchFamily="34" charset="0"/>
-                <a:ea typeface="Calibri" pitchFamily="34" charset="-122"/>
-                <a:cs typeface="Calibri" pitchFamily="34" charset="-120"/>
-              </a:rPr>
-              <a:t>Fondateur &amp; Ingénieur</a:t>
-            </a:r>
-            <a:endParaRPr lang="en-US" sz="1300" dirty="0"/>
-          </a:p>
-        </p:txBody>
-      </p:sp>
-      <p:sp>
-        <p:nvSpPr>
-          <p:cNvPr id="9" name="Text 7"/>
-          <p:cNvSpPr txBox="1"/>
-          <p:nvPr/>
-        </p:nvSpPr>
-        <p:spPr>
-          <a:xfrm>
-            <a:off x="886968" y="3749040"/>
-            <a:ext cx="4613148" cy="822960"/>
+            <a:off x="795528" y="2697480"/>
+            <a:ext cx="3044952" cy="822960"/>
           </a:xfrm>
           <a:prstGeom prst="rect">
             <a:avLst/>
@@ -2933,7 +3156,7 @@
           <a:bodyPr wrap="square" lIns="0" tIns="0" rIns="0" bIns="0" rtlCol="0" anchor="t"/>
           <a:lstStyle/>
           <a:p>
-            <a:pPr algn="ctr" indent="0" marL="0">
+            <a:pPr indent="0" marL="0">
               <a:lnSpc>
                 <a:spcPct val="110000"/>
               </a:lnSpc>
@@ -2948,7 +3171,7 @@
                 <a:ea typeface="Calibri" pitchFamily="34" charset="-122"/>
                 <a:cs typeface="Calibri" pitchFamily="34" charset="-120"/>
               </a:rPr>
-              <a:t>Application, agent IA, firmware/FluidNC, systèmes temps réel. A construit Forgeron de bout en bout.</a:t>
+              <a:t>Ethiopian AI Institute — durcir l'agent, viser l'edge / on-device</a:t>
             </a:r>
             <a:endParaRPr lang="en-US" sz="1250" dirty="0"/>
           </a:p>
@@ -2956,18 +3179,18 @@
       </p:sp>
       <p:sp>
         <p:nvSpPr>
-          <p:cNvPr id="10" name="Shape 8"/>
+          <p:cNvPr id="8" name="Shape 6"/>
           <p:cNvSpPr/>
           <p:nvPr/>
         </p:nvSpPr>
         <p:spPr>
           <a:xfrm>
-            <a:off x="6368796" y="1554480"/>
-            <a:ext cx="5253228" cy="3108960"/>
+            <a:off x="4343400" y="1417320"/>
+            <a:ext cx="3502152" cy="2194560"/>
           </a:xfrm>
           <a:prstGeom prst="roundRect">
             <a:avLst>
-              <a:gd name="adj" fmla="val 2647"/>
+              <a:gd name="adj" fmla="val 3750"/>
             </a:avLst>
           </a:prstGeom>
           <a:solidFill>
@@ -2983,41 +3206,25 @@
       </p:sp>
       <p:sp>
         <p:nvSpPr>
-          <p:cNvPr id="11" name="Shape 9"/>
-          <p:cNvSpPr/>
-          <p:nvPr/>
-        </p:nvSpPr>
-        <p:spPr>
-          <a:xfrm>
-            <a:off x="8492490" y="1828800"/>
-            <a:ext cx="1005840" cy="1005840"/>
-          </a:xfrm>
-          <a:prstGeom prst="ellipse">
-            <a:avLst/>
+          <p:cNvPr id="9" name="Text 7"/>
+          <p:cNvSpPr txBox="1"/>
+          <p:nvPr/>
+        </p:nvSpPr>
+        <p:spPr>
+          <a:xfrm>
+            <a:off x="4572000" y="1645920"/>
+            <a:ext cx="457200" cy="457200"/>
+          </a:xfrm>
+          <a:prstGeom prst="roundRect">
+            <a:avLst>
+              <a:gd name="adj" fmla="val 14000"/>
+            </a:avLst>
           </a:prstGeom>
           <a:solidFill>
-            <a:srgbClr val="FF8C42"/>
+            <a:srgbClr val="FF6A1A"/>
           </a:solidFill>
           <a:ln/>
         </p:spPr>
-      </p:sp>
-      <p:sp>
-        <p:nvSpPr>
-          <p:cNvPr id="12" name="Text 10"/>
-          <p:cNvSpPr txBox="1"/>
-          <p:nvPr/>
-        </p:nvSpPr>
-        <p:spPr>
-          <a:xfrm>
-            <a:off x="8492490" y="1828800"/>
-            <a:ext cx="1005840" cy="1005840"/>
-          </a:xfrm>
-          <a:prstGeom prst="rect">
-            <a:avLst/>
-          </a:prstGeom>
-          <a:noFill/>
-          <a:ln/>
-        </p:spPr>
         <p:txBody>
           <a:bodyPr wrap="square" lIns="0" tIns="0" rIns="0" bIns="0" rtlCol="0" anchor="ctr"/>
           <a:lstStyle/>
@@ -3026,7 +3233,7 @@
               <a:buNone/>
             </a:pPr>
             <a:r>
-              <a:rPr lang="en-US" sz="2400" b="1" dirty="0">
+              <a:rPr lang="en-US" sz="1600" b="1" dirty="0">
                 <a:solidFill>
                   <a:srgbClr val="FFFFFF"/>
                 </a:solidFill>
@@ -3034,22 +3241,22 @@
                 <a:ea typeface="Calibri" pitchFamily="34" charset="-122"/>
                 <a:cs typeface="Calibri" pitchFamily="34" charset="-120"/>
               </a:rPr>
-              <a:t>AD</a:t>
-            </a:r>
-            <a:endParaRPr lang="en-US" sz="2400" dirty="0"/>
-          </a:p>
-        </p:txBody>
-      </p:sp>
-      <p:sp>
-        <p:nvSpPr>
-          <p:cNvPr id="13" name="Text 11"/>
-          <p:cNvSpPr txBox="1"/>
-          <p:nvPr/>
-        </p:nvSpPr>
-        <p:spPr>
-          <a:xfrm>
-            <a:off x="6551676" y="2971800"/>
-            <a:ext cx="4887468" cy="411480"/>
+              <a:t>2</a:t>
+            </a:r>
+            <a:endParaRPr lang="en-US" sz="1600" dirty="0"/>
+          </a:p>
+        </p:txBody>
+      </p:sp>
+      <p:sp>
+        <p:nvSpPr>
+          <p:cNvPr id="10" name="Text 8"/>
+          <p:cNvSpPr txBox="1"/>
+          <p:nvPr/>
+        </p:nvSpPr>
+        <p:spPr>
+          <a:xfrm>
+            <a:off x="4572000" y="2240280"/>
+            <a:ext cx="3044952" cy="457200"/>
           </a:xfrm>
           <a:prstGeom prst="rect">
             <a:avLst/>
@@ -3061,11 +3268,11 @@
           <a:bodyPr wrap="square" lIns="0" tIns="0" rIns="0" bIns="0" rtlCol="0" anchor="ctr"/>
           <a:lstStyle/>
           <a:p>
-            <a:pPr algn="ctr" indent="0" marL="0">
-              <a:buNone/>
-            </a:pPr>
-            <a:r>
-              <a:rPr lang="en-US" sz="1800" b="1" dirty="0">
+            <a:pPr indent="0" marL="0">
+              <a:buNone/>
+            </a:pPr>
+            <a:r>
+              <a:rPr lang="en-US" sz="1600" b="1" dirty="0">
                 <a:solidFill>
                   <a:srgbClr val="FFFFFF"/>
                 </a:solidFill>
@@ -3073,61 +3280,22 @@
                 <a:ea typeface="Calibri" pitchFamily="34" charset="-122"/>
                 <a:cs typeface="Calibri" pitchFamily="34" charset="-120"/>
               </a:rPr>
-              <a:t>Aboubacar DIAMOUTÉNÉ</a:t>
-            </a:r>
-            <a:endParaRPr lang="en-US" sz="1800" dirty="0"/>
-          </a:p>
-        </p:txBody>
-      </p:sp>
-      <p:sp>
-        <p:nvSpPr>
-          <p:cNvPr id="14" name="Text 12"/>
-          <p:cNvSpPr txBox="1"/>
-          <p:nvPr/>
-        </p:nvSpPr>
-        <p:spPr>
-          <a:xfrm>
-            <a:off x="6551676" y="3383280"/>
-            <a:ext cx="4887468" cy="320040"/>
-          </a:xfrm>
-          <a:prstGeom prst="rect">
-            <a:avLst/>
-          </a:prstGeom>
-          <a:noFill/>
-          <a:ln/>
-        </p:spPr>
-        <p:txBody>
-          <a:bodyPr wrap="square" lIns="0" tIns="0" rIns="0" bIns="0" rtlCol="0" anchor="ctr"/>
-          <a:lstStyle/>
-          <a:p>
-            <a:pPr algn="ctr" indent="0" marL="0">
-              <a:buNone/>
-            </a:pPr>
-            <a:r>
-              <a:rPr lang="en-US" sz="1300" b="1" dirty="0">
-                <a:solidFill>
-                  <a:srgbClr val="FF8C42"/>
-                </a:solidFill>
-                <a:latin typeface="Calibri" pitchFamily="34" charset="0"/>
-                <a:ea typeface="Calibri" pitchFamily="34" charset="-122"/>
-                <a:cs typeface="Calibri" pitchFamily="34" charset="-120"/>
-              </a:rPr>
-              <a:t>Technicien électronique &amp; assemblage</a:t>
-            </a:r>
-            <a:endParaRPr lang="en-US" sz="1300" dirty="0"/>
-          </a:p>
-        </p:txBody>
-      </p:sp>
-      <p:sp>
-        <p:nvSpPr>
-          <p:cNvPr id="15" name="Text 13"/>
-          <p:cNvSpPr txBox="1"/>
-          <p:nvPr/>
-        </p:nvSpPr>
-        <p:spPr>
-          <a:xfrm>
-            <a:off x="6688836" y="3749040"/>
-            <a:ext cx="4613148" cy="822960"/>
+              <a:t>Pilotes terrain</a:t>
+            </a:r>
+            <a:endParaRPr lang="en-US" sz="1600" dirty="0"/>
+          </a:p>
+        </p:txBody>
+      </p:sp>
+      <p:sp>
+        <p:nvSpPr>
+          <p:cNvPr id="11" name="Text 9"/>
+          <p:cNvSpPr txBox="1"/>
+          <p:nvPr/>
+        </p:nvSpPr>
+        <p:spPr>
+          <a:xfrm>
+            <a:off x="4572000" y="2697480"/>
+            <a:ext cx="3044952" cy="822960"/>
           </a:xfrm>
           <a:prstGeom prst="rect">
             <a:avLst/>
@@ -3139,7 +3307,7 @@
           <a:bodyPr wrap="square" lIns="0" tIns="0" rIns="0" bIns="0" rtlCol="0" anchor="t"/>
           <a:lstStyle/>
           <a:p>
-            <a:pPr algn="ctr" indent="0" marL="0">
+            <a:pPr indent="0" marL="0">
               <a:lnSpc>
                 <a:spcPct val="110000"/>
               </a:lnSpc>
@@ -3154,7 +3322,7 @@
                 <a:ea typeface="Calibri" pitchFamily="34" charset="-122"/>
                 <a:cs typeface="Calibri" pitchFamily="34" charset="-120"/>
               </a:rPr>
-              <a:t>Câblage, drivers moteurs (TB6600), montage et tests de la machine 5-axes.</a:t>
+              <a:t>déployer chez Kouratechnique + ⟦ 2–3 ⟧ ateliers pilotes</a:t>
             </a:r>
             <a:endParaRPr lang="en-US" sz="1250" dirty="0"/>
           </a:p>
@@ -3162,19 +3330,50 @@
       </p:sp>
       <p:sp>
         <p:nvSpPr>
-          <p:cNvPr id="16" name="Text 14"/>
-          <p:cNvSpPr txBox="1"/>
-          <p:nvPr/>
-        </p:nvSpPr>
-        <p:spPr>
-          <a:xfrm>
-            <a:off x="566928" y="4892040"/>
-            <a:ext cx="11055096" cy="365760"/>
-          </a:xfrm>
-          <a:prstGeom prst="rect">
-            <a:avLst/>
-          </a:prstGeom>
-          <a:noFill/>
+          <p:cNvPr id="12" name="Shape 10"/>
+          <p:cNvSpPr/>
+          <p:nvPr/>
+        </p:nvSpPr>
+        <p:spPr>
+          <a:xfrm>
+            <a:off x="8119872" y="1417320"/>
+            <a:ext cx="3502152" cy="2194560"/>
+          </a:xfrm>
+          <a:prstGeom prst="roundRect">
+            <a:avLst>
+              <a:gd name="adj" fmla="val 3750"/>
+            </a:avLst>
+          </a:prstGeom>
+          <a:solidFill>
+            <a:srgbClr val="242E3B"/>
+          </a:solidFill>
+          <a:ln w="12700">
+            <a:solidFill>
+              <a:srgbClr val="2B3644"/>
+            </a:solidFill>
+            <a:prstDash val="solid"/>
+          </a:ln>
+        </p:spPr>
+      </p:sp>
+      <p:sp>
+        <p:nvSpPr>
+          <p:cNvPr id="13" name="Text 11"/>
+          <p:cNvSpPr txBox="1"/>
+          <p:nvPr/>
+        </p:nvSpPr>
+        <p:spPr>
+          <a:xfrm>
+            <a:off x="8348472" y="1645920"/>
+            <a:ext cx="457200" cy="457200"/>
+          </a:xfrm>
+          <a:prstGeom prst="roundRect">
+            <a:avLst>
+              <a:gd name="adj" fmla="val 14000"/>
+            </a:avLst>
+          </a:prstGeom>
+          <a:solidFill>
+            <a:srgbClr val="FF6A1A"/>
+          </a:solidFill>
           <a:ln/>
         </p:spPr>
         <p:txBody>
@@ -3185,7 +3384,88 @@
               <a:buNone/>
             </a:pPr>
             <a:r>
-              <a:rPr lang="en-US" sz="1300" dirty="0">
+              <a:rPr lang="en-US" sz="1600" b="1" dirty="0">
+                <a:solidFill>
+                  <a:srgbClr val="FFFFFF"/>
+                </a:solidFill>
+                <a:latin typeface="Calibri" pitchFamily="34" charset="0"/>
+                <a:ea typeface="Calibri" pitchFamily="34" charset="-122"/>
+                <a:cs typeface="Calibri" pitchFamily="34" charset="-120"/>
+              </a:rPr>
+              <a:t>3</a:t>
+            </a:r>
+            <a:endParaRPr lang="en-US" sz="1600" dirty="0"/>
+          </a:p>
+        </p:txBody>
+      </p:sp>
+      <p:sp>
+        <p:nvSpPr>
+          <p:cNvPr id="14" name="Text 12"/>
+          <p:cNvSpPr txBox="1"/>
+          <p:nvPr/>
+        </p:nvSpPr>
+        <p:spPr>
+          <a:xfrm>
+            <a:off x="8348472" y="2240280"/>
+            <a:ext cx="3044952" cy="457200"/>
+          </a:xfrm>
+          <a:prstGeom prst="rect">
+            <a:avLst/>
+          </a:prstGeom>
+          <a:noFill/>
+          <a:ln/>
+        </p:spPr>
+        <p:txBody>
+          <a:bodyPr wrap="square" lIns="0" tIns="0" rIns="0" bIns="0" rtlCol="0" anchor="ctr"/>
+          <a:lstStyle/>
+          <a:p>
+            <a:pPr indent="0" marL="0">
+              <a:buNone/>
+            </a:pPr>
+            <a:r>
+              <a:rPr lang="en-US" sz="1600" b="1" dirty="0">
+                <a:solidFill>
+                  <a:srgbClr val="FFFFFF"/>
+                </a:solidFill>
+                <a:latin typeface="Calibri" pitchFamily="34" charset="0"/>
+                <a:ea typeface="Calibri" pitchFamily="34" charset="-122"/>
+                <a:cs typeface="Calibri" pitchFamily="34" charset="-120"/>
+              </a:rPr>
+              <a:t>Venture (Wadhwani)</a:t>
+            </a:r>
+            <a:endParaRPr lang="en-US" sz="1600" dirty="0"/>
+          </a:p>
+        </p:txBody>
+      </p:sp>
+      <p:sp>
+        <p:nvSpPr>
+          <p:cNvPr id="15" name="Text 13"/>
+          <p:cNvSpPr txBox="1"/>
+          <p:nvPr/>
+        </p:nvSpPr>
+        <p:spPr>
+          <a:xfrm>
+            <a:off x="8348472" y="2697480"/>
+            <a:ext cx="3044952" cy="822960"/>
+          </a:xfrm>
+          <a:prstGeom prst="rect">
+            <a:avLst/>
+          </a:prstGeom>
+          <a:noFill/>
+          <a:ln/>
+        </p:spPr>
+        <p:txBody>
+          <a:bodyPr wrap="square" lIns="0" tIns="0" rIns="0" bIns="0" rtlCol="0" anchor="t"/>
+          <a:lstStyle/>
+          <a:p>
+            <a:pPr indent="0" marL="0">
+              <a:lnSpc>
+                <a:spcPct val="110000"/>
+              </a:lnSpc>
+              <a:buNone/>
+            </a:pPr>
+            <a:r>
+              <a:rPr lang="en-US" sz="1250" dirty="0">
                 <a:solidFill>
                   <a:srgbClr val="9AA6B2"/>
                 </a:solidFill>
@@ -3193,49 +3473,260 @@
                 <a:ea typeface="Calibri" pitchFamily="34" charset="-122"/>
                 <a:cs typeface="Calibri" pitchFamily="34" charset="-120"/>
               </a:rPr>
-              <a:t>Partenaire : </a:t>
-            </a:r>
-            <a:pPr algn="ctr" indent="0" marL="0">
+              <a:t>customer discovery, business model, go-to-market, investment readiness</a:t>
+            </a:r>
+            <a:endParaRPr lang="en-US" sz="1250" dirty="0"/>
+          </a:p>
+        </p:txBody>
+      </p:sp>
+      <p:sp>
+        <p:nvSpPr>
+          <p:cNvPr id="16" name="Shape 14"/>
+          <p:cNvSpPr/>
+          <p:nvPr/>
+        </p:nvSpPr>
+        <p:spPr>
+          <a:xfrm>
+            <a:off x="566928" y="3840480"/>
+            <a:ext cx="11055096" cy="1554480"/>
+          </a:xfrm>
+          <a:prstGeom prst="roundRect">
+            <a:avLst>
+              <a:gd name="adj" fmla="val 5294"/>
+            </a:avLst>
+          </a:prstGeom>
+          <a:solidFill>
+            <a:srgbClr val="2B3644"/>
+          </a:solidFill>
+          <a:ln w="12700">
+            <a:solidFill>
+              <a:srgbClr val="2B3644"/>
+            </a:solidFill>
+            <a:prstDash val="solid"/>
+          </a:ln>
+        </p:spPr>
+      </p:sp>
+      <p:sp>
+        <p:nvSpPr>
+          <p:cNvPr id="17" name="Text 15"/>
+          <p:cNvSpPr txBox="1"/>
+          <p:nvPr/>
+        </p:nvSpPr>
+        <p:spPr>
+          <a:xfrm>
+            <a:off x="841248" y="3977640"/>
+            <a:ext cx="5486400" cy="320040"/>
+          </a:xfrm>
+          <a:prstGeom prst="rect">
+            <a:avLst/>
+          </a:prstGeom>
+          <a:noFill/>
+          <a:ln/>
+        </p:spPr>
+        <p:txBody>
+          <a:bodyPr wrap="square" lIns="0" tIns="0" rIns="0" bIns="0" rtlCol="0" anchor="ctr"/>
+          <a:lstStyle/>
+          <a:p>
+            <a:pPr indent="0" marL="0">
               <a:buNone/>
             </a:pPr>
             <a:r>
               <a:rPr lang="en-US" sz="1300" b="1" dirty="0">
                 <a:solidFill>
+                  <a:srgbClr val="FFB347"/>
+                </a:solidFill>
+                <a:latin typeface="Calibri" pitchFamily="34" charset="0"/>
+                <a:ea typeface="Calibri" pitchFamily="34" charset="-122"/>
+                <a:cs typeface="Calibri" pitchFamily="34" charset="-120"/>
+              </a:rPr>
+              <a:t>Si financement d'amorçage</a:t>
+            </a:r>
+            <a:endParaRPr lang="en-US" sz="1300" dirty="0"/>
+          </a:p>
+        </p:txBody>
+      </p:sp>
+      <p:sp>
+        <p:nvSpPr>
+          <p:cNvPr id="18" name="Text 16"/>
+          <p:cNvSpPr txBox="1"/>
+          <p:nvPr/>
+        </p:nvSpPr>
+        <p:spPr>
+          <a:xfrm>
+            <a:off x="886968" y="4343400"/>
+            <a:ext cx="10415016" cy="960120"/>
+          </a:xfrm>
+          <a:prstGeom prst="rect">
+            <a:avLst/>
+          </a:prstGeom>
+          <a:noFill/>
+          <a:ln/>
+        </p:spPr>
+        <p:txBody>
+          <a:bodyPr wrap="square" lIns="0" tIns="0" rIns="0" bIns="0" rtlCol="0" anchor="t"/>
+          <a:lstStyle/>
+          <a:p>
+            <a:pPr indent="0" marL="0">
+              <a:lnSpc>
+                <a:spcPct val="120000"/>
+              </a:lnSpc>
+              <a:buNone/>
+            </a:pPr>
+            <a:r>
+              <a:rPr lang="en-US" sz="1400" dirty="0">
+                <a:solidFill>
                   <a:srgbClr val="EAECEF"/>
                 </a:solidFill>
                 <a:latin typeface="Calibri" pitchFamily="34" charset="0"/>
                 <a:ea typeface="Calibri" pitchFamily="34" charset="-122"/>
                 <a:cs typeface="Calibri" pitchFamily="34" charset="-120"/>
               </a:rPr>
-              <a:t>Kouratechnique</a:t>
-            </a:r>
-            <a:pPr algn="ctr" indent="0" marL="0">
-              <a:buNone/>
-            </a:pPr>
-            <a:r>
-              <a:rPr lang="en-US" sz="1300" dirty="0">
-                <a:solidFill>
-                  <a:srgbClr val="9AA6B2"/>
-                </a:solidFill>
-                <a:latin typeface="Calibri" pitchFamily="34" charset="0"/>
-                <a:ea typeface="Calibri" pitchFamily="34" charset="-122"/>
-                <a:cs typeface="Calibri" pitchFamily="34" charset="-120"/>
-              </a:rPr>
-              <a:t>  (atelier / terrain de test).</a:t>
-            </a:r>
-            <a:endParaRPr lang="en-US" sz="1300" dirty="0"/>
-          </a:p>
-        </p:txBody>
-      </p:sp>
-      <p:sp>
-        <p:nvSpPr>
-          <p:cNvPr id="17" name="Text 15"/>
-          <p:cNvSpPr txBox="1"/>
-          <p:nvPr/>
-        </p:nvSpPr>
-        <p:spPr>
-          <a:xfrm>
-            <a:off x="566928" y="6455664"/>
+              <a:t>Hardware &amp; pièces pour pilotes : </a:t>
+            </a:r>
+            <a:pPr indent="0" marL="0">
+              <a:lnSpc>
+                <a:spcPct val="120000"/>
+              </a:lnSpc>
+              <a:buNone/>
+            </a:pPr>
+            <a:r>
+              <a:rPr lang="en-US" sz="1400" b="1" dirty="0">
+                <a:solidFill>
+                  <a:srgbClr val="FFB347"/>
+                </a:solidFill>
+                <a:latin typeface="Calibri" pitchFamily="34" charset="0"/>
+                <a:ea typeface="Calibri" pitchFamily="34" charset="-122"/>
+                <a:cs typeface="Calibri" pitchFamily="34" charset="-120"/>
+              </a:rPr>
+              <a:t>⟦ ___ FCFA ⟧</a:t>
+            </a:r>
+            <a:pPr indent="0" marL="0">
+              <a:lnSpc>
+                <a:spcPct val="120000"/>
+              </a:lnSpc>
+              <a:buNone/>
+            </a:pPr>
+            <a:r>
+              <a:rPr lang="en-US" sz="1400" dirty="0">
+                <a:solidFill>
+                  <a:srgbClr val="EAECEF"/>
+                </a:solidFill>
+                <a:latin typeface="Calibri" pitchFamily="34" charset="0"/>
+                <a:ea typeface="Calibri" pitchFamily="34" charset="-122"/>
+                <a:cs typeface="Calibri" pitchFamily="34" charset="-120"/>
+              </a:rPr>
+              <a:t>      Développement IA (edge) : </a:t>
+            </a:r>
+            <a:pPr indent="0" marL="0">
+              <a:lnSpc>
+                <a:spcPct val="120000"/>
+              </a:lnSpc>
+              <a:buNone/>
+            </a:pPr>
+            <a:r>
+              <a:rPr lang="en-US" sz="1400" b="1" dirty="0">
+                <a:solidFill>
+                  <a:srgbClr val="FFB347"/>
+                </a:solidFill>
+                <a:latin typeface="Calibri" pitchFamily="34" charset="0"/>
+                <a:ea typeface="Calibri" pitchFamily="34" charset="-122"/>
+                <a:cs typeface="Calibri" pitchFamily="34" charset="-120"/>
+              </a:rPr>
+              <a:t>⟦ ___ FCFA ⟧</a:t>
+            </a:r>
+            <a:pPr indent="0" marL="0">
+              <a:lnSpc>
+                <a:spcPct val="120000"/>
+              </a:lnSpc>
+              <a:buNone/>
+            </a:pPr>
+            <a:endParaRPr lang="en-US" sz="1400" dirty="0"/>
+          </a:p>
+          <a:p>
+            <a:pPr indent="0" marL="0">
+              <a:lnSpc>
+                <a:spcPct val="120000"/>
+              </a:lnSpc>
+              <a:buNone/>
+            </a:pPr>
+            <a:r>
+              <a:rPr lang="en-US" sz="1400" dirty="0">
+                <a:solidFill>
+                  <a:srgbClr val="EAECEF"/>
+                </a:solidFill>
+                <a:latin typeface="Calibri" pitchFamily="34" charset="0"/>
+                <a:ea typeface="Calibri" pitchFamily="34" charset="-122"/>
+                <a:cs typeface="Calibri" pitchFamily="34" charset="-120"/>
+              </a:rPr>
+              <a:t>Fonds de roulement : </a:t>
+            </a:r>
+            <a:endParaRPr lang="en-US" sz="1400" dirty="0"/>
+          </a:p>
+          <a:p>
+            <a:pPr indent="0" marL="0">
+              <a:lnSpc>
+                <a:spcPct val="120000"/>
+              </a:lnSpc>
+              <a:buNone/>
+            </a:pPr>
+            <a:r>
+              <a:rPr lang="en-US" sz="1400" b="1" dirty="0">
+                <a:solidFill>
+                  <a:srgbClr val="FFB347"/>
+                </a:solidFill>
+                <a:latin typeface="Calibri" pitchFamily="34" charset="0"/>
+                <a:ea typeface="Calibri" pitchFamily="34" charset="-122"/>
+                <a:cs typeface="Calibri" pitchFamily="34" charset="-120"/>
+              </a:rPr>
+              <a:t>⟦ ___ FCFA ⟧</a:t>
+            </a:r>
+            <a:pPr indent="0" marL="0">
+              <a:lnSpc>
+                <a:spcPct val="120000"/>
+              </a:lnSpc>
+              <a:buNone/>
+            </a:pPr>
+            <a:r>
+              <a:rPr lang="en-US" sz="1400" dirty="0">
+                <a:solidFill>
+                  <a:srgbClr val="EAECEF"/>
+                </a:solidFill>
+                <a:latin typeface="Calibri" pitchFamily="34" charset="0"/>
+                <a:ea typeface="Calibri" pitchFamily="34" charset="-122"/>
+                <a:cs typeface="Calibri" pitchFamily="34" charset="-120"/>
+              </a:rPr>
+              <a:t>      Marketing &amp; démos : </a:t>
+            </a:r>
+            <a:pPr indent="0" marL="0">
+              <a:lnSpc>
+                <a:spcPct val="120000"/>
+              </a:lnSpc>
+              <a:buNone/>
+            </a:pPr>
+            <a:r>
+              <a:rPr lang="en-US" sz="1400" b="1" dirty="0">
+                <a:solidFill>
+                  <a:srgbClr val="FFB347"/>
+                </a:solidFill>
+                <a:latin typeface="Calibri" pitchFamily="34" charset="0"/>
+                <a:ea typeface="Calibri" pitchFamily="34" charset="-122"/>
+                <a:cs typeface="Calibri" pitchFamily="34" charset="-120"/>
+              </a:rPr>
+              <a:t>⟦ ___ FCFA ⟧</a:t>
+            </a:r>
+            <a:endParaRPr lang="en-US" sz="1400" dirty="0"/>
+          </a:p>
+        </p:txBody>
+      </p:sp>
+      <p:sp>
+        <p:nvSpPr>
+          <p:cNvPr id="19" name="Text 17"/>
+          <p:cNvSpPr txBox="1"/>
+          <p:nvPr/>
+        </p:nvSpPr>
+        <p:spPr>
+          <a:xfrm>
+            <a:off x="566928" y="6473952"/>
             <a:ext cx="11055096" cy="274320"/>
           </a:xfrm>
           <a:prstGeom prst="rect">
@@ -3248,7 +3739,7 @@
           <a:bodyPr wrap="square" lIns="0" tIns="0" rIns="0" bIns="0" rtlCol="0" anchor="ctr"/>
           <a:lstStyle/>
           <a:p>
-            <a:pPr algn="l" indent="0" marL="0">
+            <a:pPr indent="0" marL="0">
               <a:buNone/>
             </a:pPr>
             <a:r>
@@ -3277,6 +3768,844 @@
 <file path=ppt/slides/slide12.xml><?xml version="1.0" encoding="utf-8"?>
 <p:sld xmlns:a="http://schemas.openxmlformats.org/drawingml/2006/main" xmlns:r="http://schemas.openxmlformats.org/officeDocument/2006/relationships" xmlns:p="http://schemas.openxmlformats.org/presentationml/2006/main">
   <p:cSld name="Slide 12">
+    <p:bg>
+      <p:bgPr>
+        <a:solidFill>
+          <a:srgbClr val="141821"/>
+        </a:solidFill>
+      </p:bgPr>
+    </p:bg>
+    <p:spTree>
+      <p:nvGrpSpPr>
+        <p:cNvPr id="1" name=""/>
+        <p:cNvGrpSpPr/>
+        <p:nvPr/>
+      </p:nvGrpSpPr>
+      <p:grpSpPr>
+        <a:xfrm>
+          <a:off x="0" y="0"/>
+          <a:ext cx="0" cy="0"/>
+          <a:chOff x="0" y="0"/>
+          <a:chExt cx="0" cy="0"/>
+        </a:xfrm>
+      </p:grpSpPr>
+      <p:sp>
+        <p:nvSpPr>
+          <p:cNvPr id="2" name="Text 0"/>
+          <p:cNvSpPr txBox="1"/>
+          <p:nvPr/>
+        </p:nvSpPr>
+        <p:spPr>
+          <a:xfrm>
+            <a:off x="566928" y="457200"/>
+            <a:ext cx="420624" cy="420624"/>
+          </a:xfrm>
+          <a:prstGeom prst="roundRect">
+            <a:avLst>
+              <a:gd name="adj" fmla="val 15217"/>
+            </a:avLst>
+          </a:prstGeom>
+          <a:solidFill>
+            <a:srgbClr val="FF6A1A"/>
+          </a:solidFill>
+          <a:ln/>
+        </p:spPr>
+        <p:txBody>
+          <a:bodyPr wrap="square" lIns="0" tIns="0" rIns="0" bIns="0" rtlCol="0" anchor="ctr"/>
+          <a:lstStyle/>
+          <a:p>
+            <a:pPr algn="ctr" indent="0" marL="0">
+              <a:buNone/>
+            </a:pPr>
+            <a:r>
+              <a:rPr lang="en-US" sz="1900" b="1" dirty="0">
+                <a:solidFill>
+                  <a:srgbClr val="FFFFFF"/>
+                </a:solidFill>
+                <a:latin typeface="Calibri" pitchFamily="34" charset="0"/>
+                <a:ea typeface="Calibri" pitchFamily="34" charset="-122"/>
+                <a:cs typeface="Calibri" pitchFamily="34" charset="-120"/>
+              </a:rPr>
+              <a:t>10</a:t>
+            </a:r>
+            <a:endParaRPr lang="en-US" sz="1900" dirty="0"/>
+          </a:p>
+        </p:txBody>
+      </p:sp>
+      <p:sp>
+        <p:nvSpPr>
+          <p:cNvPr id="3" name="Text 1"/>
+          <p:cNvSpPr txBox="1"/>
+          <p:nvPr/>
+        </p:nvSpPr>
+        <p:spPr>
+          <a:xfrm>
+            <a:off x="1133856" y="420624"/>
+            <a:ext cx="10506456" cy="566928"/>
+          </a:xfrm>
+          <a:prstGeom prst="rect">
+            <a:avLst/>
+          </a:prstGeom>
+          <a:noFill/>
+          <a:ln/>
+        </p:spPr>
+        <p:txBody>
+          <a:bodyPr wrap="square" lIns="0" tIns="0" rIns="0" bIns="0" rtlCol="0" anchor="ctr"/>
+          <a:lstStyle/>
+          <a:p>
+            <a:pPr algn="l" indent="0" marL="0">
+              <a:buNone/>
+            </a:pPr>
+            <a:r>
+              <a:rPr lang="en-US" sz="2800" b="1" dirty="0">
+                <a:solidFill>
+                  <a:srgbClr val="FFFFFF"/>
+                </a:solidFill>
+                <a:latin typeface="Calibri" pitchFamily="34" charset="0"/>
+                <a:ea typeface="Calibri" pitchFamily="34" charset="-122"/>
+                <a:cs typeface="Calibri" pitchFamily="34" charset="-120"/>
+              </a:rPr>
+              <a:t>L'équipe</a:t>
+            </a:r>
+            <a:endParaRPr lang="en-US" sz="2800" dirty="0"/>
+          </a:p>
+        </p:txBody>
+      </p:sp>
+      <p:sp>
+        <p:nvSpPr>
+          <p:cNvPr id="4" name="Shape 2"/>
+          <p:cNvSpPr/>
+          <p:nvPr/>
+        </p:nvSpPr>
+        <p:spPr>
+          <a:xfrm>
+            <a:off x="566928" y="1554480"/>
+            <a:ext cx="3471672" cy="3291840"/>
+          </a:xfrm>
+          <a:prstGeom prst="roundRect">
+            <a:avLst>
+              <a:gd name="adj" fmla="val 2500"/>
+            </a:avLst>
+          </a:prstGeom>
+          <a:solidFill>
+            <a:srgbClr val="242E3B"/>
+          </a:solidFill>
+          <a:ln w="12700">
+            <a:solidFill>
+              <a:srgbClr val="2B3644"/>
+            </a:solidFill>
+            <a:prstDash val="solid"/>
+          </a:ln>
+        </p:spPr>
+      </p:sp>
+      <p:sp>
+        <p:nvSpPr>
+          <p:cNvPr id="5" name="Shape 3"/>
+          <p:cNvSpPr/>
+          <p:nvPr/>
+        </p:nvSpPr>
+        <p:spPr>
+          <a:xfrm>
+            <a:off x="1845564" y="1783080"/>
+            <a:ext cx="914400" cy="914400"/>
+          </a:xfrm>
+          <a:prstGeom prst="ellipse">
+            <a:avLst/>
+          </a:prstGeom>
+          <a:solidFill>
+            <a:srgbClr val="FF6A1A"/>
+          </a:solidFill>
+          <a:ln/>
+        </p:spPr>
+      </p:sp>
+      <p:sp>
+        <p:nvSpPr>
+          <p:cNvPr id="6" name="Text 4"/>
+          <p:cNvSpPr txBox="1"/>
+          <p:nvPr/>
+        </p:nvSpPr>
+        <p:spPr>
+          <a:xfrm>
+            <a:off x="1845564" y="1783080"/>
+            <a:ext cx="914400" cy="914400"/>
+          </a:xfrm>
+          <a:prstGeom prst="rect">
+            <a:avLst/>
+          </a:prstGeom>
+          <a:noFill/>
+          <a:ln/>
+        </p:spPr>
+        <p:txBody>
+          <a:bodyPr wrap="square" lIns="0" tIns="0" rIns="0" bIns="0" rtlCol="0" anchor="ctr"/>
+          <a:lstStyle/>
+          <a:p>
+            <a:pPr algn="ctr" indent="0" marL="0">
+              <a:buNone/>
+            </a:pPr>
+            <a:r>
+              <a:rPr lang="en-US" sz="2200" b="1" dirty="0">
+                <a:solidFill>
+                  <a:srgbClr val="FFFFFF"/>
+                </a:solidFill>
+                <a:latin typeface="Calibri" pitchFamily="34" charset="0"/>
+                <a:ea typeface="Calibri" pitchFamily="34" charset="-122"/>
+                <a:cs typeface="Calibri" pitchFamily="34" charset="-120"/>
+              </a:rPr>
+              <a:t>LS</a:t>
+            </a:r>
+            <a:endParaRPr lang="en-US" sz="2200" dirty="0"/>
+          </a:p>
+        </p:txBody>
+      </p:sp>
+      <p:sp>
+        <p:nvSpPr>
+          <p:cNvPr id="7" name="Text 5"/>
+          <p:cNvSpPr txBox="1"/>
+          <p:nvPr/>
+        </p:nvSpPr>
+        <p:spPr>
+          <a:xfrm>
+            <a:off x="704088" y="2834640"/>
+            <a:ext cx="3197352" cy="365760"/>
+          </a:xfrm>
+          <a:prstGeom prst="rect">
+            <a:avLst/>
+          </a:prstGeom>
+          <a:noFill/>
+          <a:ln/>
+        </p:spPr>
+        <p:txBody>
+          <a:bodyPr wrap="square" lIns="0" tIns="0" rIns="0" bIns="0" rtlCol="0" anchor="t"/>
+          <a:lstStyle/>
+          <a:p>
+            <a:pPr algn="ctr" indent="0" marL="0">
+              <a:buNone/>
+            </a:pPr>
+            <a:r>
+              <a:rPr lang="en-US" sz="1500" b="1" dirty="0">
+                <a:solidFill>
+                  <a:srgbClr val="FFFFFF"/>
+                </a:solidFill>
+                <a:latin typeface="Calibri" pitchFamily="34" charset="0"/>
+                <a:ea typeface="Calibri" pitchFamily="34" charset="-122"/>
+                <a:cs typeface="Calibri" pitchFamily="34" charset="-120"/>
+              </a:rPr>
+              <a:t>Lamine SACKO</a:t>
+            </a:r>
+            <a:endParaRPr lang="en-US" sz="1500" dirty="0"/>
+          </a:p>
+        </p:txBody>
+      </p:sp>
+      <p:sp>
+        <p:nvSpPr>
+          <p:cNvPr id="8" name="Text 6"/>
+          <p:cNvSpPr txBox="1"/>
+          <p:nvPr/>
+        </p:nvSpPr>
+        <p:spPr>
+          <a:xfrm>
+            <a:off x="704088" y="3218688"/>
+            <a:ext cx="3197352" cy="457200"/>
+          </a:xfrm>
+          <a:prstGeom prst="rect">
+            <a:avLst/>
+          </a:prstGeom>
+          <a:noFill/>
+          <a:ln/>
+        </p:spPr>
+        <p:txBody>
+          <a:bodyPr wrap="square" lIns="0" tIns="0" rIns="0" bIns="0" rtlCol="0" anchor="t"/>
+          <a:lstStyle/>
+          <a:p>
+            <a:pPr algn="ctr" indent="0" marL="0">
+              <a:buNone/>
+            </a:pPr>
+            <a:r>
+              <a:rPr lang="en-US" sz="1200" b="1" dirty="0">
+                <a:solidFill>
+                  <a:srgbClr val="FF6A1A"/>
+                </a:solidFill>
+                <a:latin typeface="Calibri" pitchFamily="34" charset="0"/>
+                <a:ea typeface="Calibri" pitchFamily="34" charset="-122"/>
+                <a:cs typeface="Calibri" pitchFamily="34" charset="-120"/>
+              </a:rPr>
+              <a:t>Fondateur &amp; Ingénieur</a:t>
+            </a:r>
+            <a:endParaRPr lang="en-US" sz="1200" dirty="0"/>
+          </a:p>
+        </p:txBody>
+      </p:sp>
+      <p:sp>
+        <p:nvSpPr>
+          <p:cNvPr id="9" name="Text 7"/>
+          <p:cNvSpPr txBox="1"/>
+          <p:nvPr/>
+        </p:nvSpPr>
+        <p:spPr>
+          <a:xfrm>
+            <a:off x="841248" y="3767328"/>
+            <a:ext cx="2923032" cy="960120"/>
+          </a:xfrm>
+          <a:prstGeom prst="rect">
+            <a:avLst/>
+          </a:prstGeom>
+          <a:noFill/>
+          <a:ln/>
+        </p:spPr>
+        <p:txBody>
+          <a:bodyPr wrap="square" lIns="0" tIns="0" rIns="0" bIns="0" rtlCol="0" anchor="t"/>
+          <a:lstStyle/>
+          <a:p>
+            <a:pPr algn="ctr" indent="0" marL="0">
+              <a:lnSpc>
+                <a:spcPct val="110000"/>
+              </a:lnSpc>
+              <a:buNone/>
+            </a:pPr>
+            <a:r>
+              <a:rPr lang="en-US" sz="1150" dirty="0">
+                <a:solidFill>
+                  <a:srgbClr val="9AA6B2"/>
+                </a:solidFill>
+                <a:latin typeface="Calibri" pitchFamily="34" charset="0"/>
+                <a:ea typeface="Calibri" pitchFamily="34" charset="-122"/>
+                <a:cs typeface="Calibri" pitchFamily="34" charset="-120"/>
+              </a:rPr>
+              <a:t>Application, agent IA, firmware/FluidNC, temps réel. A construit Forgeron de bout en bout.</a:t>
+            </a:r>
+            <a:endParaRPr lang="en-US" sz="1150" dirty="0"/>
+          </a:p>
+        </p:txBody>
+      </p:sp>
+      <p:sp>
+        <p:nvSpPr>
+          <p:cNvPr id="10" name="Shape 8"/>
+          <p:cNvSpPr/>
+          <p:nvPr/>
+        </p:nvSpPr>
+        <p:spPr>
+          <a:xfrm>
+            <a:off x="4358640" y="1554480"/>
+            <a:ext cx="3471672" cy="3291840"/>
+          </a:xfrm>
+          <a:prstGeom prst="roundRect">
+            <a:avLst>
+              <a:gd name="adj" fmla="val 2500"/>
+            </a:avLst>
+          </a:prstGeom>
+          <a:solidFill>
+            <a:srgbClr val="242E3B"/>
+          </a:solidFill>
+          <a:ln w="12700">
+            <a:solidFill>
+              <a:srgbClr val="2B3644"/>
+            </a:solidFill>
+            <a:prstDash val="solid"/>
+          </a:ln>
+        </p:spPr>
+      </p:sp>
+      <p:sp>
+        <p:nvSpPr>
+          <p:cNvPr id="11" name="Shape 9"/>
+          <p:cNvSpPr/>
+          <p:nvPr/>
+        </p:nvSpPr>
+        <p:spPr>
+          <a:xfrm>
+            <a:off x="5637276" y="1783080"/>
+            <a:ext cx="914400" cy="914400"/>
+          </a:xfrm>
+          <a:prstGeom prst="ellipse">
+            <a:avLst/>
+          </a:prstGeom>
+          <a:solidFill>
+            <a:srgbClr val="FF8C42"/>
+          </a:solidFill>
+          <a:ln/>
+        </p:spPr>
+      </p:sp>
+      <p:sp>
+        <p:nvSpPr>
+          <p:cNvPr id="12" name="Text 10"/>
+          <p:cNvSpPr txBox="1"/>
+          <p:nvPr/>
+        </p:nvSpPr>
+        <p:spPr>
+          <a:xfrm>
+            <a:off x="5637276" y="1783080"/>
+            <a:ext cx="914400" cy="914400"/>
+          </a:xfrm>
+          <a:prstGeom prst="rect">
+            <a:avLst/>
+          </a:prstGeom>
+          <a:noFill/>
+          <a:ln/>
+        </p:spPr>
+        <p:txBody>
+          <a:bodyPr wrap="square" lIns="0" tIns="0" rIns="0" bIns="0" rtlCol="0" anchor="ctr"/>
+          <a:lstStyle/>
+          <a:p>
+            <a:pPr algn="ctr" indent="0" marL="0">
+              <a:buNone/>
+            </a:pPr>
+            <a:r>
+              <a:rPr lang="en-US" sz="2200" b="1" dirty="0">
+                <a:solidFill>
+                  <a:srgbClr val="FFFFFF"/>
+                </a:solidFill>
+                <a:latin typeface="Calibri" pitchFamily="34" charset="0"/>
+                <a:ea typeface="Calibri" pitchFamily="34" charset="-122"/>
+                <a:cs typeface="Calibri" pitchFamily="34" charset="-120"/>
+              </a:rPr>
+              <a:t>AD</a:t>
+            </a:r>
+            <a:endParaRPr lang="en-US" sz="2200" dirty="0"/>
+          </a:p>
+        </p:txBody>
+      </p:sp>
+      <p:sp>
+        <p:nvSpPr>
+          <p:cNvPr id="13" name="Text 11"/>
+          <p:cNvSpPr txBox="1"/>
+          <p:nvPr/>
+        </p:nvSpPr>
+        <p:spPr>
+          <a:xfrm>
+            <a:off x="4495800" y="2834640"/>
+            <a:ext cx="3197352" cy="365760"/>
+          </a:xfrm>
+          <a:prstGeom prst="rect">
+            <a:avLst/>
+          </a:prstGeom>
+          <a:noFill/>
+          <a:ln/>
+        </p:spPr>
+        <p:txBody>
+          <a:bodyPr wrap="square" lIns="0" tIns="0" rIns="0" bIns="0" rtlCol="0" anchor="t"/>
+          <a:lstStyle/>
+          <a:p>
+            <a:pPr algn="ctr" indent="0" marL="0">
+              <a:buNone/>
+            </a:pPr>
+            <a:r>
+              <a:rPr lang="en-US" sz="1500" b="1" dirty="0">
+                <a:solidFill>
+                  <a:srgbClr val="FFFFFF"/>
+                </a:solidFill>
+                <a:latin typeface="Calibri" pitchFamily="34" charset="0"/>
+                <a:ea typeface="Calibri" pitchFamily="34" charset="-122"/>
+                <a:cs typeface="Calibri" pitchFamily="34" charset="-120"/>
+              </a:rPr>
+              <a:t>Aboubacar DIAMOUTÉNÉ</a:t>
+            </a:r>
+            <a:endParaRPr lang="en-US" sz="1500" dirty="0"/>
+          </a:p>
+        </p:txBody>
+      </p:sp>
+      <p:sp>
+        <p:nvSpPr>
+          <p:cNvPr id="14" name="Text 12"/>
+          <p:cNvSpPr txBox="1"/>
+          <p:nvPr/>
+        </p:nvSpPr>
+        <p:spPr>
+          <a:xfrm>
+            <a:off x="4495800" y="3218688"/>
+            <a:ext cx="3197352" cy="457200"/>
+          </a:xfrm>
+          <a:prstGeom prst="rect">
+            <a:avLst/>
+          </a:prstGeom>
+          <a:noFill/>
+          <a:ln/>
+        </p:spPr>
+        <p:txBody>
+          <a:bodyPr wrap="square" lIns="0" tIns="0" rIns="0" bIns="0" rtlCol="0" anchor="t"/>
+          <a:lstStyle/>
+          <a:p>
+            <a:pPr algn="ctr" indent="0" marL="0">
+              <a:buNone/>
+            </a:pPr>
+            <a:r>
+              <a:rPr lang="en-US" sz="1200" b="1" dirty="0">
+                <a:solidFill>
+                  <a:srgbClr val="FF8C42"/>
+                </a:solidFill>
+                <a:latin typeface="Calibri" pitchFamily="34" charset="0"/>
+                <a:ea typeface="Calibri" pitchFamily="34" charset="-122"/>
+                <a:cs typeface="Calibri" pitchFamily="34" charset="-120"/>
+              </a:rPr>
+              <a:t>Technicien électronique &amp; assemblage</a:t>
+            </a:r>
+            <a:endParaRPr lang="en-US" sz="1200" dirty="0"/>
+          </a:p>
+        </p:txBody>
+      </p:sp>
+      <p:sp>
+        <p:nvSpPr>
+          <p:cNvPr id="15" name="Text 13"/>
+          <p:cNvSpPr txBox="1"/>
+          <p:nvPr/>
+        </p:nvSpPr>
+        <p:spPr>
+          <a:xfrm>
+            <a:off x="4632960" y="3767328"/>
+            <a:ext cx="2923032" cy="960120"/>
+          </a:xfrm>
+          <a:prstGeom prst="rect">
+            <a:avLst/>
+          </a:prstGeom>
+          <a:noFill/>
+          <a:ln/>
+        </p:spPr>
+        <p:txBody>
+          <a:bodyPr wrap="square" lIns="0" tIns="0" rIns="0" bIns="0" rtlCol="0" anchor="t"/>
+          <a:lstStyle/>
+          <a:p>
+            <a:pPr algn="ctr" indent="0" marL="0">
+              <a:lnSpc>
+                <a:spcPct val="110000"/>
+              </a:lnSpc>
+              <a:buNone/>
+            </a:pPr>
+            <a:r>
+              <a:rPr lang="en-US" sz="1150" dirty="0">
+                <a:solidFill>
+                  <a:srgbClr val="9AA6B2"/>
+                </a:solidFill>
+                <a:latin typeface="Calibri" pitchFamily="34" charset="0"/>
+                <a:ea typeface="Calibri" pitchFamily="34" charset="-122"/>
+                <a:cs typeface="Calibri" pitchFamily="34" charset="-120"/>
+              </a:rPr>
+              <a:t>Câblage, drivers moteurs (TB6600), montage &amp; tests de la machine.</a:t>
+            </a:r>
+            <a:endParaRPr lang="en-US" sz="1150" dirty="0"/>
+          </a:p>
+        </p:txBody>
+      </p:sp>
+      <p:sp>
+        <p:nvSpPr>
+          <p:cNvPr id="16" name="Shape 14"/>
+          <p:cNvSpPr/>
+          <p:nvPr/>
+        </p:nvSpPr>
+        <p:spPr>
+          <a:xfrm>
+            <a:off x="8150352" y="1554480"/>
+            <a:ext cx="3471672" cy="3291840"/>
+          </a:xfrm>
+          <a:prstGeom prst="roundRect">
+            <a:avLst>
+              <a:gd name="adj" fmla="val 2500"/>
+            </a:avLst>
+          </a:prstGeom>
+          <a:solidFill>
+            <a:srgbClr val="242E3B"/>
+          </a:solidFill>
+          <a:ln w="12700">
+            <a:solidFill>
+              <a:srgbClr val="2B3644"/>
+            </a:solidFill>
+            <a:prstDash val="solid"/>
+          </a:ln>
+        </p:spPr>
+      </p:sp>
+      <p:sp>
+        <p:nvSpPr>
+          <p:cNvPr id="17" name="Shape 15"/>
+          <p:cNvSpPr/>
+          <p:nvPr/>
+        </p:nvSpPr>
+        <p:spPr>
+          <a:xfrm>
+            <a:off x="9428988" y="1783080"/>
+            <a:ext cx="914400" cy="914400"/>
+          </a:xfrm>
+          <a:prstGeom prst="ellipse">
+            <a:avLst/>
+          </a:prstGeom>
+          <a:solidFill>
+            <a:srgbClr val="6E7A88"/>
+          </a:solidFill>
+          <a:ln/>
+        </p:spPr>
+      </p:sp>
+      <p:sp>
+        <p:nvSpPr>
+          <p:cNvPr id="18" name="Text 16"/>
+          <p:cNvSpPr txBox="1"/>
+          <p:nvPr/>
+        </p:nvSpPr>
+        <p:spPr>
+          <a:xfrm>
+            <a:off x="9428988" y="1783080"/>
+            <a:ext cx="914400" cy="914400"/>
+          </a:xfrm>
+          <a:prstGeom prst="rect">
+            <a:avLst/>
+          </a:prstGeom>
+          <a:noFill/>
+          <a:ln/>
+        </p:spPr>
+        <p:txBody>
+          <a:bodyPr wrap="square" lIns="0" tIns="0" rIns="0" bIns="0" rtlCol="0" anchor="ctr"/>
+          <a:lstStyle/>
+          <a:p>
+            <a:pPr algn="ctr" indent="0" marL="0">
+              <a:buNone/>
+            </a:pPr>
+            <a:r>
+              <a:rPr lang="en-US" sz="2200" b="1" dirty="0">
+                <a:solidFill>
+                  <a:srgbClr val="FFFFFF"/>
+                </a:solidFill>
+                <a:latin typeface="Calibri" pitchFamily="34" charset="0"/>
+                <a:ea typeface="Calibri" pitchFamily="34" charset="-122"/>
+                <a:cs typeface="Calibri" pitchFamily="34" charset="-120"/>
+              </a:rPr>
+              <a:t>?</a:t>
+            </a:r>
+            <a:endParaRPr lang="en-US" sz="2200" dirty="0"/>
+          </a:p>
+        </p:txBody>
+      </p:sp>
+      <p:sp>
+        <p:nvSpPr>
+          <p:cNvPr id="19" name="Text 17"/>
+          <p:cNvSpPr txBox="1"/>
+          <p:nvPr/>
+        </p:nvSpPr>
+        <p:spPr>
+          <a:xfrm>
+            <a:off x="8287512" y="2834640"/>
+            <a:ext cx="3197352" cy="365760"/>
+          </a:xfrm>
+          <a:prstGeom prst="rect">
+            <a:avLst/>
+          </a:prstGeom>
+          <a:noFill/>
+          <a:ln/>
+        </p:spPr>
+        <p:txBody>
+          <a:bodyPr wrap="square" lIns="0" tIns="0" rIns="0" bIns="0" rtlCol="0" anchor="t"/>
+          <a:lstStyle/>
+          <a:p>
+            <a:pPr algn="ctr" indent="0" marL="0">
+              <a:buNone/>
+            </a:pPr>
+            <a:r>
+              <a:rPr lang="en-US" sz="1500" b="1" dirty="0">
+                <a:solidFill>
+                  <a:srgbClr val="FFFFFF"/>
+                </a:solidFill>
+                <a:latin typeface="Calibri" pitchFamily="34" charset="0"/>
+                <a:ea typeface="Calibri" pitchFamily="34" charset="-122"/>
+                <a:cs typeface="Calibri" pitchFamily="34" charset="-120"/>
+              </a:rPr>
+              <a:t>Poste ouvert</a:t>
+            </a:r>
+            <a:endParaRPr lang="en-US" sz="1500" dirty="0"/>
+          </a:p>
+        </p:txBody>
+      </p:sp>
+      <p:sp>
+        <p:nvSpPr>
+          <p:cNvPr id="20" name="Text 18"/>
+          <p:cNvSpPr txBox="1"/>
+          <p:nvPr/>
+        </p:nvSpPr>
+        <p:spPr>
+          <a:xfrm>
+            <a:off x="8287512" y="3218688"/>
+            <a:ext cx="3197352" cy="457200"/>
+          </a:xfrm>
+          <a:prstGeom prst="rect">
+            <a:avLst/>
+          </a:prstGeom>
+          <a:noFill/>
+          <a:ln/>
+        </p:spPr>
+        <p:txBody>
+          <a:bodyPr wrap="square" lIns="0" tIns="0" rIns="0" bIns="0" rtlCol="0" anchor="t"/>
+          <a:lstStyle/>
+          <a:p>
+            <a:pPr algn="ctr" indent="0" marL="0">
+              <a:buNone/>
+            </a:pPr>
+            <a:r>
+              <a:rPr lang="en-US" sz="1200" b="1" dirty="0">
+                <a:solidFill>
+                  <a:srgbClr val="9AA6B2"/>
+                </a:solidFill>
+                <a:latin typeface="Calibri" pitchFamily="34" charset="0"/>
+                <a:ea typeface="Calibri" pitchFamily="34" charset="-122"/>
+                <a:cs typeface="Calibri" pitchFamily="34" charset="-120"/>
+              </a:rPr>
+              <a:t>Business / Commercial</a:t>
+            </a:r>
+            <a:endParaRPr lang="en-US" sz="1200" dirty="0"/>
+          </a:p>
+        </p:txBody>
+      </p:sp>
+      <p:sp>
+        <p:nvSpPr>
+          <p:cNvPr id="21" name="Text 19"/>
+          <p:cNvSpPr txBox="1"/>
+          <p:nvPr/>
+        </p:nvSpPr>
+        <p:spPr>
+          <a:xfrm>
+            <a:off x="8424672" y="3767328"/>
+            <a:ext cx="2923032" cy="960120"/>
+          </a:xfrm>
+          <a:prstGeom prst="rect">
+            <a:avLst/>
+          </a:prstGeom>
+          <a:noFill/>
+          <a:ln/>
+        </p:spPr>
+        <p:txBody>
+          <a:bodyPr wrap="square" lIns="0" tIns="0" rIns="0" bIns="0" rtlCol="0" anchor="t"/>
+          <a:lstStyle/>
+          <a:p>
+            <a:pPr algn="ctr" indent="0" marL="0">
+              <a:lnSpc>
+                <a:spcPct val="110000"/>
+              </a:lnSpc>
+              <a:buNone/>
+            </a:pPr>
+            <a:r>
+              <a:rPr lang="en-US" sz="1150" dirty="0">
+                <a:solidFill>
+                  <a:srgbClr val="9AA6B2"/>
+                </a:solidFill>
+                <a:latin typeface="Calibri" pitchFamily="34" charset="0"/>
+                <a:ea typeface="Calibri" pitchFamily="34" charset="-122"/>
+                <a:cs typeface="Calibri" pitchFamily="34" charset="-120"/>
+              </a:rPr>
+              <a:t>Développement commercial &amp; partenariats — profil recherché via le programme.</a:t>
+            </a:r>
+            <a:endParaRPr lang="en-US" sz="1150" dirty="0"/>
+          </a:p>
+        </p:txBody>
+      </p:sp>
+      <p:sp>
+        <p:nvSpPr>
+          <p:cNvPr id="22" name="Text 20"/>
+          <p:cNvSpPr txBox="1"/>
+          <p:nvPr/>
+        </p:nvSpPr>
+        <p:spPr>
+          <a:xfrm>
+            <a:off x="566928" y="5029200"/>
+            <a:ext cx="11055096" cy="365760"/>
+          </a:xfrm>
+          <a:prstGeom prst="rect">
+            <a:avLst/>
+          </a:prstGeom>
+          <a:noFill/>
+          <a:ln/>
+        </p:spPr>
+        <p:txBody>
+          <a:bodyPr wrap="square" lIns="0" tIns="0" rIns="0" bIns="0" rtlCol="0" anchor="ctr"/>
+          <a:lstStyle/>
+          <a:p>
+            <a:pPr algn="ctr" indent="0" marL="0">
+              <a:buNone/>
+            </a:pPr>
+            <a:r>
+              <a:rPr lang="en-US" sz="1300" dirty="0">
+                <a:solidFill>
+                  <a:srgbClr val="9AA6B2"/>
+                </a:solidFill>
+                <a:latin typeface="Calibri" pitchFamily="34" charset="0"/>
+                <a:ea typeface="Calibri" pitchFamily="34" charset="-122"/>
+                <a:cs typeface="Calibri" pitchFamily="34" charset="-120"/>
+              </a:rPr>
+              <a:t>Partenaire : </a:t>
+            </a:r>
+            <a:pPr algn="ctr" indent="0" marL="0">
+              <a:buNone/>
+            </a:pPr>
+            <a:r>
+              <a:rPr lang="en-US" sz="1300" b="1" dirty="0">
+                <a:solidFill>
+                  <a:srgbClr val="EAECEF"/>
+                </a:solidFill>
+                <a:latin typeface="Calibri" pitchFamily="34" charset="0"/>
+                <a:ea typeface="Calibri" pitchFamily="34" charset="-122"/>
+                <a:cs typeface="Calibri" pitchFamily="34" charset="-120"/>
+              </a:rPr>
+              <a:t>Kouratechnique</a:t>
+            </a:r>
+            <a:pPr algn="ctr" indent="0" marL="0">
+              <a:buNone/>
+            </a:pPr>
+            <a:r>
+              <a:rPr lang="en-US" sz="1300" dirty="0">
+                <a:solidFill>
+                  <a:srgbClr val="9AA6B2"/>
+                </a:solidFill>
+                <a:latin typeface="Calibri" pitchFamily="34" charset="0"/>
+                <a:ea typeface="Calibri" pitchFamily="34" charset="-122"/>
+                <a:cs typeface="Calibri" pitchFamily="34" charset="-120"/>
+              </a:rPr>
+              <a:t>  (atelier / terrain de test).</a:t>
+            </a:r>
+            <a:endParaRPr lang="en-US" sz="1300" dirty="0"/>
+          </a:p>
+        </p:txBody>
+      </p:sp>
+      <p:sp>
+        <p:nvSpPr>
+          <p:cNvPr id="23" name="Text 21"/>
+          <p:cNvSpPr txBox="1"/>
+          <p:nvPr/>
+        </p:nvSpPr>
+        <p:spPr>
+          <a:xfrm>
+            <a:off x="566928" y="6473952"/>
+            <a:ext cx="11055096" cy="274320"/>
+          </a:xfrm>
+          <a:prstGeom prst="rect">
+            <a:avLst/>
+          </a:prstGeom>
+          <a:noFill/>
+          <a:ln/>
+        </p:spPr>
+        <p:txBody>
+          <a:bodyPr wrap="square" lIns="0" tIns="0" rIns="0" bIns="0" rtlCol="0" anchor="ctr"/>
+          <a:lstStyle/>
+          <a:p>
+            <a:pPr indent="0" marL="0">
+              <a:buNone/>
+            </a:pPr>
+            <a:r>
+              <a:rPr lang="en-US" sz="900" dirty="0">
+                <a:solidFill>
+                  <a:srgbClr val="6E7A88"/>
+                </a:solidFill>
+                <a:latin typeface="Calibri" pitchFamily="34" charset="0"/>
+                <a:ea typeface="Calibri" pitchFamily="34" charset="-122"/>
+                <a:cs typeface="Calibri" pitchFamily="34" charset="-120"/>
+              </a:rPr>
+              <a:t>Forgeron · Pitch UNIPOD AI 2024 — 12</a:t>
+            </a:r>
+            <a:endParaRPr lang="en-US" sz="900" dirty="0"/>
+          </a:p>
+        </p:txBody>
+      </p:sp>
+    </p:spTree>
+  </p:cSld>
+  <p:clrMapOvr>
+    <a:masterClrMapping/>
+  </p:clrMapOvr>
+</p:sld>
+</file>
+
+<file path=ppt/slides/slide13.xml><?xml version="1.0" encoding="utf-8"?>
+<p:sld xmlns:a="http://schemas.openxmlformats.org/drawingml/2006/main" xmlns:r="http://schemas.openxmlformats.org/officeDocument/2006/relationships" xmlns:p="http://schemas.openxmlformats.org/presentationml/2006/main">
+  <p:cSld name="Slide 13">
     <p:bg>
       <p:bgPr>
         <a:solidFill>
@@ -3490,7 +4819,7 @@
                 <a:ea typeface="Calibri" pitchFamily="34" charset="-122"/>
                 <a:cs typeface="Calibri" pitchFamily="34" charset="-120"/>
               </a:rPr>
-              <a:t>Ethiopian AI Institute — durcir l'agent, viser l'edge / on-device</a:t>
+              <a:t>Ethiopian AI Institute — durcir l'agent, edge / on-device</a:t>
             </a:r>
             <a:endParaRPr lang="en-US" sz="1400" dirty="0"/>
           </a:p>
@@ -3757,7 +5086,7 @@
                 <a:ea typeface="Calibri" pitchFamily="34" charset="-122"/>
                 <a:cs typeface="Calibri" pitchFamily="34" charset="-120"/>
               </a:rPr>
-              <a:t>des contrôleurs Forgeron dans les ateliers d'Afrique de l'Ouest et de l'Est — produire localement ce qui est aujourd'hui importé, et créer des emplois qualifiés.</a:t>
+              <a:t>des contrôleurs Forgeron dans les ateliers d'Afrique de l'Ouest et de l'Est — produire localement ce qui est importé, et créer des emplois qualifiés.</a:t>
             </a:r>
             <a:endParaRPr lang="en-US" sz="1550" dirty="0"/>
           </a:p>
@@ -3977,12 +5306,12 @@
         </p:nvSpPr>
         <p:spPr>
           <a:xfrm>
-            <a:off x="566928" y="1371600"/>
-            <a:ext cx="4297680" cy="2743200"/>
+            <a:off x="566928" y="1417320"/>
+            <a:ext cx="3502152" cy="2331720"/>
           </a:xfrm>
           <a:prstGeom prst="roundRect">
             <a:avLst>
-              <a:gd name="adj" fmla="val 3000"/>
+              <a:gd name="adj" fmla="val 3529"/>
             </a:avLst>
           </a:prstGeom>
           <a:solidFill>
@@ -4004,8 +5333,8 @@
         </p:nvSpPr>
         <p:spPr>
           <a:xfrm>
-            <a:off x="841248" y="2148840"/>
-            <a:ext cx="3749040" cy="731520"/>
+            <a:off x="749808" y="1673352"/>
+            <a:ext cx="3136392" cy="822960"/>
           </a:xfrm>
           <a:prstGeom prst="rect">
             <a:avLst/>
@@ -4017,11 +5346,11 @@
           <a:bodyPr wrap="square" lIns="0" tIns="0" rIns="0" bIns="0" rtlCol="0" anchor="ctr"/>
           <a:lstStyle/>
           <a:p>
-            <a:pPr indent="0" marL="0">
-              <a:buNone/>
-            </a:pPr>
-            <a:r>
-              <a:rPr lang="en-US" sz="2900" b="1" dirty="0">
+            <a:pPr algn="ctr" indent="0" marL="0">
+              <a:buNone/>
+            </a:pPr>
+            <a:r>
+              <a:rPr lang="en-US" sz="3400" b="1" dirty="0">
                 <a:solidFill>
                   <a:srgbClr val="FF6A1A"/>
                 </a:solidFill>
@@ -4031,7 +5360,7 @@
               </a:rPr>
               <a:t>5 000 – 50 000 $</a:t>
             </a:r>
-            <a:endParaRPr lang="en-US" sz="2900" dirty="0"/>
+            <a:endParaRPr lang="en-US" sz="3400" dirty="0"/>
           </a:p>
         </p:txBody>
       </p:sp>
@@ -4043,8 +5372,50 @@
         </p:nvSpPr>
         <p:spPr>
           <a:xfrm>
-            <a:off x="886968" y="2971800"/>
-            <a:ext cx="3657600" cy="914400"/>
+            <a:off x="768096" y="2514600"/>
+            <a:ext cx="3099816" cy="822960"/>
+          </a:xfrm>
+          <a:prstGeom prst="rect">
+            <a:avLst/>
+          </a:prstGeom>
+          <a:noFill/>
+          <a:ln/>
+        </p:spPr>
+        <p:txBody>
+          <a:bodyPr wrap="square" lIns="0" tIns="0" rIns="0" bIns="0" rtlCol="0" anchor="t"/>
+          <a:lstStyle/>
+          <a:p>
+            <a:pPr algn="ctr" indent="0" marL="0">
+              <a:lnSpc>
+                <a:spcPct val="105000"/>
+              </a:lnSpc>
+              <a:buNone/>
+            </a:pPr>
+            <a:r>
+              <a:rPr lang="en-US" sz="1300" dirty="0">
+                <a:solidFill>
+                  <a:srgbClr val="EAECEF"/>
+                </a:solidFill>
+                <a:latin typeface="Calibri" pitchFamily="34" charset="0"/>
+                <a:ea typeface="Calibri" pitchFamily="34" charset="-122"/>
+                <a:cs typeface="Calibri" pitchFamily="34" charset="-120"/>
+              </a:rPr>
+              <a:t>Prix d'un contrôleur CNC 5-axes industriel</a:t>
+            </a:r>
+            <a:endParaRPr lang="en-US" sz="1300" dirty="0"/>
+          </a:p>
+        </p:txBody>
+      </p:sp>
+      <p:sp>
+        <p:nvSpPr>
+          <p:cNvPr id="7" name="Text 5"/>
+          <p:cNvSpPr txBox="1"/>
+          <p:nvPr/>
+        </p:nvSpPr>
+        <p:spPr>
+          <a:xfrm>
+            <a:off x="749808" y="3383280"/>
+            <a:ext cx="3136392" cy="274320"/>
           </a:xfrm>
           <a:prstGeom prst="rect">
             <a:avLst/>
@@ -4056,38 +5427,38 @@
           <a:bodyPr wrap="square" lIns="0" tIns="0" rIns="0" bIns="0" rtlCol="0" anchor="ctr"/>
           <a:lstStyle/>
           <a:p>
-            <a:pPr indent="0" marL="0">
-              <a:buNone/>
-            </a:pPr>
-            <a:r>
-              <a:rPr lang="en-US" sz="1400" dirty="0">
-                <a:solidFill>
-                  <a:srgbClr val="9AA6B2"/>
-                </a:solidFill>
-                <a:latin typeface="Calibri" pitchFamily="34" charset="0"/>
-                <a:ea typeface="Calibri" pitchFamily="34" charset="-122"/>
-                <a:cs typeface="Calibri" pitchFamily="34" charset="-120"/>
-              </a:rPr>
-              <a:t>le prix d'un contrôleur CNC 5-axes industriel (Fanuc, Heidenhain, Siemens)</a:t>
-            </a:r>
-            <a:endParaRPr lang="en-US" sz="1400" dirty="0"/>
-          </a:p>
-        </p:txBody>
-      </p:sp>
-      <p:sp>
-        <p:nvSpPr>
-          <p:cNvPr id="7" name="Shape 5"/>
+            <a:pPr algn="ctr" indent="0" marL="0">
+              <a:buNone/>
+            </a:pPr>
+            <a:r>
+              <a:rPr lang="en-US" sz="900" i="1" dirty="0">
+                <a:solidFill>
+                  <a:srgbClr val="6E7A88"/>
+                </a:solidFill>
+                <a:latin typeface="Calibri" pitchFamily="34" charset="0"/>
+                <a:ea typeface="Calibri" pitchFamily="34" charset="-122"/>
+                <a:cs typeface="Calibri" pitchFamily="34" charset="-120"/>
+              </a:rPr>
+              <a:t>Source : catalogues Fanuc / Heidenhain / Siemens</a:t>
+            </a:r>
+            <a:endParaRPr lang="en-US" sz="900" dirty="0"/>
+          </a:p>
+        </p:txBody>
+      </p:sp>
+      <p:sp>
+        <p:nvSpPr>
+          <p:cNvPr id="8" name="Shape 6"/>
           <p:cNvSpPr/>
           <p:nvPr/>
         </p:nvSpPr>
         <p:spPr>
           <a:xfrm>
-            <a:off x="5486400" y="1371600"/>
-            <a:ext cx="6135624" cy="822960"/>
+            <a:off x="4343400" y="1417320"/>
+            <a:ext cx="3502152" cy="2331720"/>
           </a:xfrm>
           <a:prstGeom prst="roundRect">
             <a:avLst>
-              <a:gd name="adj" fmla="val 10000"/>
+              <a:gd name="adj" fmla="val 3529"/>
             </a:avLst>
           </a:prstGeom>
           <a:solidFill>
@@ -4103,115 +5474,138 @@
       </p:sp>
       <p:sp>
         <p:nvSpPr>
-          <p:cNvPr id="8" name="Text 6"/>
-          <p:cNvSpPr txBox="1"/>
-          <p:nvPr/>
-        </p:nvSpPr>
-        <p:spPr>
-          <a:xfrm>
-            <a:off x="5669280" y="1554480"/>
-            <a:ext cx="457200" cy="457200"/>
+          <p:cNvPr id="9" name="Text 7"/>
+          <p:cNvSpPr txBox="1"/>
+          <p:nvPr/>
+        </p:nvSpPr>
+        <p:spPr>
+          <a:xfrm>
+            <a:off x="4526280" y="1673352"/>
+            <a:ext cx="3136392" cy="822960"/>
+          </a:xfrm>
+          <a:prstGeom prst="rect">
+            <a:avLst/>
+          </a:prstGeom>
+          <a:noFill/>
+          <a:ln/>
+        </p:spPr>
+        <p:txBody>
+          <a:bodyPr wrap="square" lIns="0" tIns="0" rIns="0" bIns="0" rtlCol="0" anchor="ctr"/>
+          <a:lstStyle/>
+          <a:p>
+            <a:pPr algn="ctr" indent="0" marL="0">
+              <a:buNone/>
+            </a:pPr>
+            <a:r>
+              <a:rPr lang="en-US" sz="3400" b="1" dirty="0">
+                <a:solidFill>
+                  <a:srgbClr val="FF8C42"/>
+                </a:solidFill>
+                <a:latin typeface="Calibri" pitchFamily="34" charset="0"/>
+                <a:ea typeface="Calibri" pitchFamily="34" charset="-122"/>
+                <a:cs typeface="Calibri" pitchFamily="34" charset="-120"/>
+              </a:rPr>
+              <a:t>≈ 2 %</a:t>
+            </a:r>
+            <a:endParaRPr lang="en-US" sz="3400" dirty="0"/>
+          </a:p>
+        </p:txBody>
+      </p:sp>
+      <p:sp>
+        <p:nvSpPr>
+          <p:cNvPr id="10" name="Text 8"/>
+          <p:cNvSpPr txBox="1"/>
+          <p:nvPr/>
+        </p:nvSpPr>
+        <p:spPr>
+          <a:xfrm>
+            <a:off x="4544568" y="2514600"/>
+            <a:ext cx="3099816" cy="822960"/>
+          </a:xfrm>
+          <a:prstGeom prst="rect">
+            <a:avLst/>
+          </a:prstGeom>
+          <a:noFill/>
+          <a:ln/>
+        </p:spPr>
+        <p:txBody>
+          <a:bodyPr wrap="square" lIns="0" tIns="0" rIns="0" bIns="0" rtlCol="0" anchor="t"/>
+          <a:lstStyle/>
+          <a:p>
+            <a:pPr algn="ctr" indent="0" marL="0">
+              <a:lnSpc>
+                <a:spcPct val="105000"/>
+              </a:lnSpc>
+              <a:buNone/>
+            </a:pPr>
+            <a:r>
+              <a:rPr lang="en-US" sz="1300" dirty="0">
+                <a:solidFill>
+                  <a:srgbClr val="EAECEF"/>
+                </a:solidFill>
+                <a:latin typeface="Calibri" pitchFamily="34" charset="0"/>
+                <a:ea typeface="Calibri" pitchFamily="34" charset="-122"/>
+                <a:cs typeface="Calibri" pitchFamily="34" charset="-120"/>
+              </a:rPr>
+              <a:t>Part de l'Afrique dans la production manufacturière mondiale</a:t>
+            </a:r>
+            <a:endParaRPr lang="en-US" sz="1300" dirty="0"/>
+          </a:p>
+        </p:txBody>
+      </p:sp>
+      <p:sp>
+        <p:nvSpPr>
+          <p:cNvPr id="11" name="Text 9"/>
+          <p:cNvSpPr txBox="1"/>
+          <p:nvPr/>
+        </p:nvSpPr>
+        <p:spPr>
+          <a:xfrm>
+            <a:off x="4526280" y="3383280"/>
+            <a:ext cx="3136392" cy="274320"/>
+          </a:xfrm>
+          <a:prstGeom prst="rect">
+            <a:avLst/>
+          </a:prstGeom>
+          <a:noFill/>
+          <a:ln/>
+        </p:spPr>
+        <p:txBody>
+          <a:bodyPr wrap="square" lIns="0" tIns="0" rIns="0" bIns="0" rtlCol="0" anchor="ctr"/>
+          <a:lstStyle/>
+          <a:p>
+            <a:pPr algn="ctr" indent="0" marL="0">
+              <a:buNone/>
+            </a:pPr>
+            <a:r>
+              <a:rPr lang="en-US" sz="900" i="1" dirty="0">
+                <a:solidFill>
+                  <a:srgbClr val="6E7A88"/>
+                </a:solidFill>
+                <a:latin typeface="Calibri" pitchFamily="34" charset="0"/>
+                <a:ea typeface="Calibri" pitchFamily="34" charset="-122"/>
+                <a:cs typeface="Calibri" pitchFamily="34" charset="-120"/>
+              </a:rPr>
+              <a:t>Source : UNIDO</a:t>
+            </a:r>
+            <a:endParaRPr lang="en-US" sz="900" dirty="0"/>
+          </a:p>
+        </p:txBody>
+      </p:sp>
+      <p:sp>
+        <p:nvSpPr>
+          <p:cNvPr id="12" name="Shape 10"/>
+          <p:cNvSpPr/>
+          <p:nvPr/>
+        </p:nvSpPr>
+        <p:spPr>
+          <a:xfrm>
+            <a:off x="8119872" y="1417320"/>
+            <a:ext cx="3502152" cy="2331720"/>
           </a:xfrm>
           <a:prstGeom prst="roundRect">
             <a:avLst>
-              <a:gd name="adj" fmla="val 14000"/>
-            </a:avLst>
-          </a:prstGeom>
-          <a:solidFill>
-            <a:srgbClr val="FF6A1A"/>
-          </a:solidFill>
-          <a:ln/>
-        </p:spPr>
-        <p:txBody>
-          <a:bodyPr wrap="square" lIns="0" tIns="0" rIns="0" bIns="0" rtlCol="0" anchor="ctr"/>
-          <a:lstStyle/>
-          <a:p>
-            <a:pPr algn="ctr" indent="0" marL="0">
-              <a:buNone/>
-            </a:pPr>
-            <a:r>
-              <a:rPr lang="en-US" sz="1600" b="1" dirty="0">
-                <a:solidFill>
-                  <a:srgbClr val="FFFFFF"/>
-                </a:solidFill>
-                <a:latin typeface="Calibri" pitchFamily="34" charset="0"/>
-                <a:ea typeface="Calibri" pitchFamily="34" charset="-122"/>
-                <a:cs typeface="Calibri" pitchFamily="34" charset="-120"/>
-              </a:rPr>
-              <a:t>1</a:t>
-            </a:r>
-            <a:endParaRPr lang="en-US" sz="1600" dirty="0"/>
-          </a:p>
-        </p:txBody>
-      </p:sp>
-      <p:sp>
-        <p:nvSpPr>
-          <p:cNvPr id="9" name="Text 7"/>
-          <p:cNvSpPr txBox="1"/>
-          <p:nvPr/>
-        </p:nvSpPr>
-        <p:spPr>
-          <a:xfrm>
-            <a:off x="6263640" y="1490472"/>
-            <a:ext cx="5266944" cy="585216"/>
-          </a:xfrm>
-          <a:prstGeom prst="rect">
-            <a:avLst/>
-          </a:prstGeom>
-          <a:noFill/>
-          <a:ln/>
-        </p:spPr>
-        <p:txBody>
-          <a:bodyPr wrap="square" lIns="0" tIns="0" rIns="0" bIns="0" rtlCol="0" anchor="ctr"/>
-          <a:lstStyle/>
-          <a:p>
-            <a:pPr indent="0" marL="0">
-              <a:buNone/>
-            </a:pPr>
-            <a:r>
-              <a:rPr lang="en-US" sz="1500" b="1" dirty="0">
-                <a:solidFill>
-                  <a:srgbClr val="EAECEF"/>
-                </a:solidFill>
-                <a:latin typeface="Calibri" pitchFamily="34" charset="0"/>
-                <a:ea typeface="Calibri" pitchFamily="34" charset="-122"/>
-                <a:cs typeface="Calibri" pitchFamily="34" charset="-120"/>
-              </a:rPr>
-              <a:t>Coût prohibitif
-</a:t>
-            </a:r>
-            <a:pPr indent="0" marL="0">
-              <a:buNone/>
-            </a:pPr>
-            <a:r>
-              <a:rPr lang="en-US" sz="1200" dirty="0">
-                <a:solidFill>
-                  <a:srgbClr val="9AA6B2"/>
-                </a:solidFill>
-                <a:latin typeface="Calibri" pitchFamily="34" charset="0"/>
-                <a:ea typeface="Calibri" pitchFamily="34" charset="-122"/>
-                <a:cs typeface="Calibri" pitchFamily="34" charset="-120"/>
-              </a:rPr>
-              <a:t>hors de portée des ateliers et PME</a:t>
-            </a:r>
-            <a:endParaRPr lang="en-US" sz="1500" dirty="0"/>
-          </a:p>
-        </p:txBody>
-      </p:sp>
-      <p:sp>
-        <p:nvSpPr>
-          <p:cNvPr id="10" name="Shape 8"/>
-          <p:cNvSpPr/>
-          <p:nvPr/>
-        </p:nvSpPr>
-        <p:spPr>
-          <a:xfrm>
-            <a:off x="5486400" y="2331720"/>
-            <a:ext cx="6135624" cy="822960"/>
-          </a:xfrm>
-          <a:prstGeom prst="roundRect">
-            <a:avLst>
-              <a:gd name="adj" fmla="val 10000"/>
+              <a:gd name="adj" fmla="val 3529"/>
             </a:avLst>
           </a:prstGeom>
           <a:solidFill>
@@ -4227,34 +5621,200 @@
       </p:sp>
       <p:sp>
         <p:nvSpPr>
-          <p:cNvPr id="11" name="Text 9"/>
-          <p:cNvSpPr txBox="1"/>
-          <p:nvPr/>
-        </p:nvSpPr>
-        <p:spPr>
-          <a:xfrm>
-            <a:off x="5669280" y="2514600"/>
-            <a:ext cx="457200" cy="457200"/>
+          <p:cNvPr id="13" name="Text 11"/>
+          <p:cNvSpPr txBox="1"/>
+          <p:nvPr/>
+        </p:nvSpPr>
+        <p:spPr>
+          <a:xfrm>
+            <a:off x="8302752" y="1673352"/>
+            <a:ext cx="3136392" cy="822960"/>
+          </a:xfrm>
+          <a:prstGeom prst="rect">
+            <a:avLst/>
+          </a:prstGeom>
+          <a:noFill/>
+          <a:ln/>
+        </p:spPr>
+        <p:txBody>
+          <a:bodyPr wrap="square" lIns="0" tIns="0" rIns="0" bIns="0" rtlCol="0" anchor="ctr"/>
+          <a:lstStyle/>
+          <a:p>
+            <a:pPr algn="ctr" indent="0" marL="0">
+              <a:buNone/>
+            </a:pPr>
+            <a:r>
+              <a:rPr lang="en-US" sz="3400" b="1" dirty="0">
+                <a:solidFill>
+                  <a:srgbClr val="FFB347"/>
+                </a:solidFill>
+                <a:latin typeface="Calibri" pitchFamily="34" charset="0"/>
+                <a:ea typeface="Calibri" pitchFamily="34" charset="-122"/>
+                <a:cs typeface="Calibri" pitchFamily="34" charset="-120"/>
+              </a:rPr>
+              <a:t>⟦ ___ % ⟧</a:t>
+            </a:r>
+            <a:endParaRPr lang="en-US" sz="3400" dirty="0"/>
+          </a:p>
+        </p:txBody>
+      </p:sp>
+      <p:sp>
+        <p:nvSpPr>
+          <p:cNvPr id="14" name="Text 12"/>
+          <p:cNvSpPr txBox="1"/>
+          <p:nvPr/>
+        </p:nvSpPr>
+        <p:spPr>
+          <a:xfrm>
+            <a:off x="8321040" y="2514600"/>
+            <a:ext cx="3099816" cy="822960"/>
+          </a:xfrm>
+          <a:prstGeom prst="rect">
+            <a:avLst/>
+          </a:prstGeom>
+          <a:noFill/>
+          <a:ln/>
+        </p:spPr>
+        <p:txBody>
+          <a:bodyPr wrap="square" lIns="0" tIns="0" rIns="0" bIns="0" rtlCol="0" anchor="t"/>
+          <a:lstStyle/>
+          <a:p>
+            <a:pPr algn="ctr" indent="0" marL="0">
+              <a:lnSpc>
+                <a:spcPct val="105000"/>
+              </a:lnSpc>
+              <a:buNone/>
+            </a:pPr>
+            <a:r>
+              <a:rPr lang="en-US" sz="1300" dirty="0">
+                <a:solidFill>
+                  <a:srgbClr val="EAECEF"/>
+                </a:solidFill>
+                <a:latin typeface="Calibri" pitchFamily="34" charset="0"/>
+                <a:ea typeface="Calibri" pitchFamily="34" charset="-122"/>
+                <a:cs typeface="Calibri" pitchFamily="34" charset="-120"/>
+              </a:rPr>
+              <a:t>de l'outillage &amp; des pièces de précision sont importés</a:t>
+            </a:r>
+            <a:endParaRPr lang="en-US" sz="1300" dirty="0"/>
+          </a:p>
+        </p:txBody>
+      </p:sp>
+      <p:sp>
+        <p:nvSpPr>
+          <p:cNvPr id="15" name="Text 13"/>
+          <p:cNvSpPr txBox="1"/>
+          <p:nvPr/>
+        </p:nvSpPr>
+        <p:spPr>
+          <a:xfrm>
+            <a:off x="8302752" y="3383280"/>
+            <a:ext cx="3136392" cy="274320"/>
+          </a:xfrm>
+          <a:prstGeom prst="rect">
+            <a:avLst/>
+          </a:prstGeom>
+          <a:noFill/>
+          <a:ln/>
+        </p:spPr>
+        <p:txBody>
+          <a:bodyPr wrap="square" lIns="0" tIns="0" rIns="0" bIns="0" rtlCol="0" anchor="ctr"/>
+          <a:lstStyle/>
+          <a:p>
+            <a:pPr algn="ctr" indent="0" marL="0">
+              <a:buNone/>
+            </a:pPr>
+            <a:r>
+              <a:rPr lang="en-US" sz="900" i="1" dirty="0">
+                <a:solidFill>
+                  <a:srgbClr val="6E7A88"/>
+                </a:solidFill>
+                <a:latin typeface="Calibri" pitchFamily="34" charset="0"/>
+                <a:ea typeface="Calibri" pitchFamily="34" charset="-122"/>
+                <a:cs typeface="Calibri" pitchFamily="34" charset="-120"/>
+              </a:rPr>
+              <a:t>Source : ⟦ à confirmer ⟧</a:t>
+            </a:r>
+            <a:endParaRPr lang="en-US" sz="900" dirty="0"/>
+          </a:p>
+        </p:txBody>
+      </p:sp>
+      <p:sp>
+        <p:nvSpPr>
+          <p:cNvPr id="16" name="Shape 14"/>
+          <p:cNvSpPr/>
+          <p:nvPr/>
+        </p:nvSpPr>
+        <p:spPr>
+          <a:xfrm>
+            <a:off x="566928" y="4114800"/>
+            <a:ext cx="11055096" cy="1371600"/>
           </a:xfrm>
           <a:prstGeom prst="roundRect">
             <a:avLst>
-              <a:gd name="adj" fmla="val 14000"/>
+              <a:gd name="adj" fmla="val 6667"/>
             </a:avLst>
           </a:prstGeom>
           <a:solidFill>
-            <a:srgbClr val="FF6A1A"/>
+            <a:srgbClr val="2B3644"/>
           </a:solidFill>
           <a:ln/>
         </p:spPr>
+      </p:sp>
+      <p:sp>
+        <p:nvSpPr>
+          <p:cNvPr id="17" name="Text 15"/>
+          <p:cNvSpPr txBox="1"/>
+          <p:nvPr/>
+        </p:nvSpPr>
+        <p:spPr>
+          <a:xfrm>
+            <a:off x="886968" y="4114800"/>
+            <a:ext cx="10415016" cy="1371600"/>
+          </a:xfrm>
+          <a:prstGeom prst="rect">
+            <a:avLst/>
+          </a:prstGeom>
+          <a:noFill/>
+          <a:ln/>
+        </p:spPr>
         <p:txBody>
           <a:bodyPr wrap="square" lIns="0" tIns="0" rIns="0" bIns="0" rtlCol="0" anchor="ctr"/>
           <a:lstStyle/>
           <a:p>
-            <a:pPr algn="ctr" indent="0" marL="0">
-              <a:buNone/>
-            </a:pPr>
-            <a:r>
-              <a:rPr lang="en-US" sz="1600" b="1" dirty="0">
+            <a:pPr indent="0" marL="0">
+              <a:buNone/>
+            </a:pPr>
+            <a:r>
+              <a:rPr lang="en-US" sz="1700" b="1" dirty="0">
+                <a:solidFill>
+                  <a:srgbClr val="FF6A1A"/>
+                </a:solidFill>
+                <a:latin typeface="Calibri" pitchFamily="34" charset="0"/>
+                <a:ea typeface="Calibri" pitchFamily="34" charset="-122"/>
+                <a:cs typeface="Calibri" pitchFamily="34" charset="-120"/>
+              </a:rPr>
+              <a:t>→  </a:t>
+            </a:r>
+            <a:pPr indent="0" marL="0">
+              <a:buNone/>
+            </a:pPr>
+            <a:r>
+              <a:rPr lang="en-US" sz="1700" dirty="0">
+                <a:solidFill>
+                  <a:srgbClr val="EAECEF"/>
+                </a:solidFill>
+                <a:latin typeface="Calibri" pitchFamily="34" charset="0"/>
+                <a:ea typeface="Calibri" pitchFamily="34" charset="-122"/>
+                <a:cs typeface="Calibri" pitchFamily="34" charset="-120"/>
+              </a:rPr>
+              <a:t>Coût + compétence = les ateliers, fablabs et PME africaines sont </a:t>
+            </a:r>
+            <a:pPr indent="0" marL="0">
+              <a:buNone/>
+            </a:pPr>
+            <a:r>
+              <a:rPr lang="en-US" sz="1700" b="1" dirty="0">
                 <a:solidFill>
                   <a:srgbClr val="FFFFFF"/>
                 </a:solidFill>
@@ -4262,22 +5822,36 @@
                 <a:ea typeface="Calibri" pitchFamily="34" charset="-122"/>
                 <a:cs typeface="Calibri" pitchFamily="34" charset="-120"/>
               </a:rPr>
-              <a:t>2</a:t>
-            </a:r>
-            <a:endParaRPr lang="en-US" sz="1600" dirty="0"/>
-          </a:p>
-        </p:txBody>
-      </p:sp>
-      <p:sp>
-        <p:nvSpPr>
-          <p:cNvPr id="12" name="Text 10"/>
-          <p:cNvSpPr txBox="1"/>
-          <p:nvPr/>
-        </p:nvSpPr>
-        <p:spPr>
-          <a:xfrm>
-            <a:off x="6263640" y="2450592"/>
-            <a:ext cx="5266944" cy="585216"/>
+              <a:t>exclus de la fabrication de précision</a:t>
+            </a:r>
+            <a:pPr indent="0" marL="0">
+              <a:buNone/>
+            </a:pPr>
+            <a:r>
+              <a:rPr lang="en-US" sz="1700" dirty="0">
+                <a:solidFill>
+                  <a:srgbClr val="EAECEF"/>
+                </a:solidFill>
+                <a:latin typeface="Calibri" pitchFamily="34" charset="0"/>
+                <a:ea typeface="Calibri" pitchFamily="34" charset="-122"/>
+                <a:cs typeface="Calibri" pitchFamily="34" charset="-120"/>
+              </a:rPr>
+              <a:t>. La valeur part à l'importation.</a:t>
+            </a:r>
+            <a:endParaRPr lang="en-US" sz="1700" dirty="0"/>
+          </a:p>
+        </p:txBody>
+      </p:sp>
+      <p:sp>
+        <p:nvSpPr>
+          <p:cNvPr id="18" name="Text 16"/>
+          <p:cNvSpPr txBox="1"/>
+          <p:nvPr/>
+        </p:nvSpPr>
+        <p:spPr>
+          <a:xfrm>
+            <a:off x="566928" y="6473952"/>
+            <a:ext cx="11055096" cy="274320"/>
           </a:xfrm>
           <a:prstGeom prst="rect">
             <a:avLst/>
@@ -4290,265 +5864,6 @@
           <a:lstStyle/>
           <a:p>
             <a:pPr indent="0" marL="0">
-              <a:buNone/>
-            </a:pPr>
-            <a:r>
-              <a:rPr lang="en-US" sz="1500" b="1" dirty="0">
-                <a:solidFill>
-                  <a:srgbClr val="EAECEF"/>
-                </a:solidFill>
-                <a:latin typeface="Calibri" pitchFamily="34" charset="0"/>
-                <a:ea typeface="Calibri" pitchFamily="34" charset="-122"/>
-                <a:cs typeface="Calibri" pitchFamily="34" charset="-120"/>
-              </a:rPr>
-              <a:t>Systèmes propriétaires &amp; fermés
-</a:t>
-            </a:r>
-            <a:pPr indent="0" marL="0">
-              <a:buNone/>
-            </a:pPr>
-            <a:r>
-              <a:rPr lang="en-US" sz="1200" dirty="0">
-                <a:solidFill>
-                  <a:srgbClr val="9AA6B2"/>
-                </a:solidFill>
-                <a:latin typeface="Calibri" pitchFamily="34" charset="0"/>
-                <a:ea typeface="Calibri" pitchFamily="34" charset="-122"/>
-                <a:cs typeface="Calibri" pitchFamily="34" charset="-120"/>
-              </a:rPr>
-              <a:t>non modifiables, non abordables</a:t>
-            </a:r>
-            <a:endParaRPr lang="en-US" sz="1500" dirty="0"/>
-          </a:p>
-        </p:txBody>
-      </p:sp>
-      <p:sp>
-        <p:nvSpPr>
-          <p:cNvPr id="13" name="Shape 11"/>
-          <p:cNvSpPr/>
-          <p:nvPr/>
-        </p:nvSpPr>
-        <p:spPr>
-          <a:xfrm>
-            <a:off x="5486400" y="3291840"/>
-            <a:ext cx="6135624" cy="822960"/>
-          </a:xfrm>
-          <a:prstGeom prst="roundRect">
-            <a:avLst>
-              <a:gd name="adj" fmla="val 10000"/>
-            </a:avLst>
-          </a:prstGeom>
-          <a:solidFill>
-            <a:srgbClr val="242E3B"/>
-          </a:solidFill>
-          <a:ln w="12700">
-            <a:solidFill>
-              <a:srgbClr val="2B3644"/>
-            </a:solidFill>
-            <a:prstDash val="solid"/>
-          </a:ln>
-        </p:spPr>
-      </p:sp>
-      <p:sp>
-        <p:nvSpPr>
-          <p:cNvPr id="14" name="Text 12"/>
-          <p:cNvSpPr txBox="1"/>
-          <p:nvPr/>
-        </p:nvSpPr>
-        <p:spPr>
-          <a:xfrm>
-            <a:off x="5669280" y="3474720"/>
-            <a:ext cx="457200" cy="457200"/>
-          </a:xfrm>
-          <a:prstGeom prst="roundRect">
-            <a:avLst>
-              <a:gd name="adj" fmla="val 14000"/>
-            </a:avLst>
-          </a:prstGeom>
-          <a:solidFill>
-            <a:srgbClr val="FF6A1A"/>
-          </a:solidFill>
-          <a:ln/>
-        </p:spPr>
-        <p:txBody>
-          <a:bodyPr wrap="square" lIns="0" tIns="0" rIns="0" bIns="0" rtlCol="0" anchor="ctr"/>
-          <a:lstStyle/>
-          <a:p>
-            <a:pPr algn="ctr" indent="0" marL="0">
-              <a:buNone/>
-            </a:pPr>
-            <a:r>
-              <a:rPr lang="en-US" sz="1600" b="1" dirty="0">
-                <a:solidFill>
-                  <a:srgbClr val="FFFFFF"/>
-                </a:solidFill>
-                <a:latin typeface="Calibri" pitchFamily="34" charset="0"/>
-                <a:ea typeface="Calibri" pitchFamily="34" charset="-122"/>
-                <a:cs typeface="Calibri" pitchFamily="34" charset="-120"/>
-              </a:rPr>
-              <a:t>3</a:t>
-            </a:r>
-            <a:endParaRPr lang="en-US" sz="1600" dirty="0"/>
-          </a:p>
-        </p:txBody>
-      </p:sp>
-      <p:sp>
-        <p:nvSpPr>
-          <p:cNvPr id="15" name="Text 13"/>
-          <p:cNvSpPr txBox="1"/>
-          <p:nvPr/>
-        </p:nvSpPr>
-        <p:spPr>
-          <a:xfrm>
-            <a:off x="6263640" y="3410712"/>
-            <a:ext cx="5266944" cy="585216"/>
-          </a:xfrm>
-          <a:prstGeom prst="rect">
-            <a:avLst/>
-          </a:prstGeom>
-          <a:noFill/>
-          <a:ln/>
-        </p:spPr>
-        <p:txBody>
-          <a:bodyPr wrap="square" lIns="0" tIns="0" rIns="0" bIns="0" rtlCol="0" anchor="ctr"/>
-          <a:lstStyle/>
-          <a:p>
-            <a:pPr indent="0" marL="0">
-              <a:buNone/>
-            </a:pPr>
-            <a:r>
-              <a:rPr lang="en-US" sz="1500" b="1" dirty="0">
-                <a:solidFill>
-                  <a:srgbClr val="EAECEF"/>
-                </a:solidFill>
-                <a:latin typeface="Calibri" pitchFamily="34" charset="0"/>
-                <a:ea typeface="Calibri" pitchFamily="34" charset="-122"/>
-                <a:cs typeface="Calibri" pitchFamily="34" charset="-120"/>
-              </a:rPr>
-              <a:t>Opérateurs hautement qualifiés
-</a:t>
-            </a:r>
-            <a:pPr indent="0" marL="0">
-              <a:buNone/>
-            </a:pPr>
-            <a:r>
-              <a:rPr lang="en-US" sz="1200" dirty="0">
-                <a:solidFill>
-                  <a:srgbClr val="9AA6B2"/>
-                </a:solidFill>
-                <a:latin typeface="Calibri" pitchFamily="34" charset="0"/>
-                <a:ea typeface="Calibri" pitchFamily="34" charset="-122"/>
-                <a:cs typeface="Calibri" pitchFamily="34" charset="-120"/>
-              </a:rPr>
-              <a:t>une compétence rare et chère</a:t>
-            </a:r>
-            <a:endParaRPr lang="en-US" sz="1500" dirty="0"/>
-          </a:p>
-        </p:txBody>
-      </p:sp>
-      <p:sp>
-        <p:nvSpPr>
-          <p:cNvPr id="16" name="Text 14"/>
-          <p:cNvSpPr txBox="1"/>
-          <p:nvPr/>
-        </p:nvSpPr>
-        <p:spPr>
-          <a:xfrm>
-            <a:off x="566928" y="4617720"/>
-            <a:ext cx="11055096" cy="1005840"/>
-          </a:xfrm>
-          <a:prstGeom prst="rect">
-            <a:avLst/>
-          </a:prstGeom>
-          <a:noFill/>
-          <a:ln/>
-        </p:spPr>
-        <p:txBody>
-          <a:bodyPr wrap="square" lIns="0" tIns="0" rIns="0" bIns="0" rtlCol="0" anchor="t"/>
-          <a:lstStyle/>
-          <a:p>
-            <a:pPr indent="0" marL="0">
-              <a:buNone/>
-            </a:pPr>
-            <a:r>
-              <a:rPr lang="en-US" sz="1500" b="1" dirty="0">
-                <a:solidFill>
-                  <a:srgbClr val="FF6A1A"/>
-                </a:solidFill>
-                <a:latin typeface="Calibri" pitchFamily="34" charset="0"/>
-                <a:ea typeface="Calibri" pitchFamily="34" charset="-122"/>
-                <a:cs typeface="Calibri" pitchFamily="34" charset="-120"/>
-              </a:rPr>
-              <a:t>→  </a:t>
-            </a:r>
-            <a:pPr indent="0" marL="0">
-              <a:buNone/>
-            </a:pPr>
-            <a:r>
-              <a:rPr lang="en-US" sz="1500" dirty="0">
-                <a:solidFill>
-                  <a:srgbClr val="EAECEF"/>
-                </a:solidFill>
-                <a:latin typeface="Calibri" pitchFamily="34" charset="0"/>
-                <a:ea typeface="Calibri" pitchFamily="34" charset="-122"/>
-                <a:cs typeface="Calibri" pitchFamily="34" charset="-120"/>
-              </a:rPr>
-              <a:t>Les ateliers, fablabs et PME manufacturières africaines sont </a:t>
-            </a:r>
-            <a:pPr indent="0" marL="0">
-              <a:buNone/>
-            </a:pPr>
-            <a:r>
-              <a:rPr lang="en-US" sz="1500" b="1" dirty="0">
-                <a:solidFill>
-                  <a:srgbClr val="FFFFFF"/>
-                </a:solidFill>
-                <a:latin typeface="Calibri" pitchFamily="34" charset="0"/>
-                <a:ea typeface="Calibri" pitchFamily="34" charset="-122"/>
-                <a:cs typeface="Calibri" pitchFamily="34" charset="-120"/>
-              </a:rPr>
-              <a:t>exclus de la fabrication de précision</a:t>
-            </a:r>
-            <a:pPr indent="0" marL="0">
-              <a:buNone/>
-            </a:pPr>
-            <a:r>
-              <a:rPr lang="en-US" sz="1500" dirty="0">
-                <a:solidFill>
-                  <a:srgbClr val="EAECEF"/>
-                </a:solidFill>
-                <a:latin typeface="Calibri" pitchFamily="34" charset="0"/>
-                <a:ea typeface="Calibri" pitchFamily="34" charset="-122"/>
-                <a:cs typeface="Calibri" pitchFamily="34" charset="-120"/>
-              </a:rPr>
-              <a:t> — et importent outillage, moules, prothèses et pièces qui pourraient être produits localement.</a:t>
-            </a:r>
-            <a:endParaRPr lang="en-US" sz="1500" dirty="0"/>
-          </a:p>
-        </p:txBody>
-      </p:sp>
-      <p:sp>
-        <p:nvSpPr>
-          <p:cNvPr id="17" name="Text 15"/>
-          <p:cNvSpPr txBox="1"/>
-          <p:nvPr/>
-        </p:nvSpPr>
-        <p:spPr>
-          <a:xfrm>
-            <a:off x="566928" y="6455664"/>
-            <a:ext cx="11055096" cy="274320"/>
-          </a:xfrm>
-          <a:prstGeom prst="rect">
-            <a:avLst/>
-          </a:prstGeom>
-          <a:noFill/>
-          <a:ln/>
-        </p:spPr>
-        <p:txBody>
-          <a:bodyPr wrap="square" lIns="0" tIns="0" rIns="0" bIns="0" rtlCol="0" anchor="ctr"/>
-          <a:lstStyle/>
-          <a:p>
-            <a:pPr algn="l" indent="0" marL="0">
               <a:buNone/>
             </a:pPr>
             <a:r>
@@ -4688,8 +6003,8 @@
         </p:nvSpPr>
         <p:spPr>
           <a:xfrm>
-            <a:off x="566928" y="1280160"/>
-            <a:ext cx="11055096" cy="914400"/>
+            <a:off x="566928" y="1234440"/>
+            <a:ext cx="11055096" cy="822960"/>
           </a:xfrm>
           <a:prstGeom prst="rect">
             <a:avLst/>
@@ -4713,7 +6028,7 @@
                 <a:ea typeface="Calibri" pitchFamily="34" charset="-122"/>
                 <a:cs typeface="Calibri" pitchFamily="34" charset="-120"/>
               </a:rPr>
-              <a:t>Forgeron transforme un microcontrôleur </a:t>
+              <a:t>Forgeron transforme un </a:t>
             </a:r>
             <a:pPr indent="0" marL="0">
               <a:buNone/>
@@ -4741,7 +6056,7 @@
                 <a:ea typeface="Calibri" pitchFamily="34" charset="-122"/>
                 <a:cs typeface="Calibri" pitchFamily="34" charset="-120"/>
               </a:rPr>
-              <a:t> (firmware open-source FluidNC) en un </a:t>
+              <a:t> (FluidNC open-source) en </a:t>
             </a:r>
             <a:pPr indent="0" marL="0">
               <a:buNone/>
@@ -4755,7 +6070,7 @@
                 <a:ea typeface="Calibri" pitchFamily="34" charset="-122"/>
                 <a:cs typeface="Calibri" pitchFamily="34" charset="-120"/>
               </a:rPr>
-              <a:t>contrôleur CNC 5-axes de grade industriel</a:t>
+              <a:t>contrôleur CNC 5-axes industriel</a:t>
             </a:r>
             <a:pPr indent="0" marL="0">
               <a:buNone/>
@@ -4783,12 +6098,12 @@
         </p:nvSpPr>
         <p:spPr>
           <a:xfrm>
-            <a:off x="566928" y="2468880"/>
-            <a:ext cx="2834640" cy="1280160"/>
+            <a:off x="566928" y="2331720"/>
+            <a:ext cx="2788920" cy="1371600"/>
           </a:xfrm>
           <a:prstGeom prst="roundRect">
             <a:avLst>
-              <a:gd name="adj" fmla="val 6429"/>
+              <a:gd name="adj" fmla="val 6000"/>
             </a:avLst>
           </a:prstGeom>
           <a:solidFill>
@@ -4810,8 +6125,8 @@
         </p:nvSpPr>
         <p:spPr>
           <a:xfrm>
-            <a:off x="566928" y="2697480"/>
-            <a:ext cx="2834640" cy="640080"/>
+            <a:off x="566928" y="2560320"/>
+            <a:ext cx="2788920" cy="685800"/>
           </a:xfrm>
           <a:prstGeom prst="rect">
             <a:avLst/>
@@ -4827,7 +6142,7 @@
               <a:buNone/>
             </a:pPr>
             <a:r>
-              <a:rPr lang="en-US" sz="3400" b="1" dirty="0">
+              <a:rPr lang="en-US" sz="3600" b="1" dirty="0">
                 <a:solidFill>
                   <a:srgbClr val="1EBE7B"/>
                 </a:solidFill>
@@ -4837,7 +6152,7 @@
               </a:rPr>
               <a:t>~8 $</a:t>
             </a:r>
-            <a:endParaRPr lang="en-US" sz="3400" dirty="0"/>
+            <a:endParaRPr lang="en-US" sz="3600" dirty="0"/>
           </a:p>
         </p:txBody>
       </p:sp>
@@ -4849,8 +6164,8 @@
         </p:nvSpPr>
         <p:spPr>
           <a:xfrm>
-            <a:off x="566928" y="3291840"/>
-            <a:ext cx="2834640" cy="365760"/>
+            <a:off x="566928" y="3246120"/>
+            <a:ext cx="2788920" cy="365760"/>
           </a:xfrm>
           <a:prstGeom prst="rect">
             <a:avLst/>
@@ -4888,8 +6203,8 @@
         </p:nvSpPr>
         <p:spPr>
           <a:xfrm>
-            <a:off x="3447288" y="2468880"/>
-            <a:ext cx="640080" cy="1280160"/>
+            <a:off x="3401568" y="2331720"/>
+            <a:ext cx="868680" cy="1371600"/>
           </a:xfrm>
           <a:prstGeom prst="rect">
             <a:avLst/>
@@ -4905,17 +6220,17 @@
               <a:buNone/>
             </a:pPr>
             <a:r>
-              <a:rPr lang="en-US" sz="1800" i="1" dirty="0">
-                <a:solidFill>
-                  <a:srgbClr val="6E7A88"/>
-                </a:solidFill>
-                <a:latin typeface="Calibri" pitchFamily="34" charset="0"/>
-                <a:ea typeface="Calibri" pitchFamily="34" charset="-122"/>
-                <a:cs typeface="Calibri" pitchFamily="34" charset="-120"/>
-              </a:rPr>
-              <a:t>vs</a:t>
-            </a:r>
-            <a:endParaRPr lang="en-US" sz="1800" dirty="0"/>
+              <a:rPr lang="en-US" sz="2000" b="1" i="1" dirty="0">
+                <a:solidFill>
+                  <a:srgbClr val="FF6A1A"/>
+                </a:solidFill>
+                <a:latin typeface="Calibri" pitchFamily="34" charset="0"/>
+                <a:ea typeface="Calibri" pitchFamily="34" charset="-122"/>
+                <a:cs typeface="Calibri" pitchFamily="34" charset="-120"/>
+              </a:rPr>
+              <a:t>−99 %</a:t>
+            </a:r>
+            <a:endParaRPr lang="en-US" sz="2000" dirty="0"/>
           </a:p>
         </p:txBody>
       </p:sp>
@@ -4927,12 +6242,12 @@
         </p:nvSpPr>
         <p:spPr>
           <a:xfrm>
-            <a:off x="4133088" y="2468880"/>
-            <a:ext cx="2834640" cy="1280160"/>
+            <a:off x="4270248" y="2331720"/>
+            <a:ext cx="2788920" cy="1371600"/>
           </a:xfrm>
           <a:prstGeom prst="roundRect">
             <a:avLst>
-              <a:gd name="adj" fmla="val 6429"/>
+              <a:gd name="adj" fmla="val 6000"/>
             </a:avLst>
           </a:prstGeom>
           <a:solidFill>
@@ -4954,8 +6269,8 @@
         </p:nvSpPr>
         <p:spPr>
           <a:xfrm>
-            <a:off x="4133088" y="2697480"/>
-            <a:ext cx="2834640" cy="640080"/>
+            <a:off x="4270248" y="2560320"/>
+            <a:ext cx="2788920" cy="685800"/>
           </a:xfrm>
           <a:prstGeom prst="rect">
             <a:avLst/>
@@ -4971,7 +6286,7 @@
               <a:buNone/>
             </a:pPr>
             <a:r>
-              <a:rPr lang="en-US" sz="3400" b="1" dirty="0">
+              <a:rPr lang="en-US" sz="3600" b="1" dirty="0">
                 <a:solidFill>
                   <a:srgbClr val="E5675E"/>
                 </a:solidFill>
@@ -4981,7 +6296,7 @@
               </a:rPr>
               <a:t>5 000 $+</a:t>
             </a:r>
-            <a:endParaRPr lang="en-US" sz="3400" dirty="0"/>
+            <a:endParaRPr lang="en-US" sz="3600" dirty="0"/>
           </a:p>
         </p:txBody>
       </p:sp>
@@ -4993,8 +6308,8 @@
         </p:nvSpPr>
         <p:spPr>
           <a:xfrm>
-            <a:off x="4133088" y="3291840"/>
-            <a:ext cx="2834640" cy="365760"/>
+            <a:off x="4270248" y="3246120"/>
+            <a:ext cx="2788920" cy="365760"/>
           </a:xfrm>
           <a:prstGeom prst="rect">
             <a:avLst/>
@@ -5032,12 +6347,12 @@
         </p:nvSpPr>
         <p:spPr>
           <a:xfrm>
-            <a:off x="6858000" y="2468880"/>
-            <a:ext cx="4764024" cy="1280160"/>
+            <a:off x="6995160" y="2331720"/>
+            <a:ext cx="4626864" cy="1371600"/>
           </a:xfrm>
           <a:prstGeom prst="roundRect">
             <a:avLst>
-              <a:gd name="adj" fmla="val 6429"/>
+              <a:gd name="adj" fmla="val 6000"/>
             </a:avLst>
           </a:prstGeom>
           <a:solidFill>
@@ -5059,8 +6374,8 @@
         </p:nvSpPr>
         <p:spPr>
           <a:xfrm>
-            <a:off x="7040880" y="2468880"/>
-            <a:ext cx="4581144" cy="1280160"/>
+            <a:off x="7178040" y="2331720"/>
+            <a:ext cx="4443984" cy="1371600"/>
           </a:xfrm>
           <a:prstGeom prst="rect">
             <a:avLst/>
@@ -5079,7 +6394,7 @@
               <a:buNone/>
             </a:pPr>
             <a:r>
-              <a:rPr lang="en-US" sz="1350" dirty="0">
+              <a:rPr lang="en-US" sz="1300" dirty="0">
                 <a:solidFill>
                   <a:srgbClr val="EAECEF"/>
                 </a:solidFill>
@@ -5089,7 +6404,7 @@
               </a:rPr>
               <a:t>DRO temps réel · Jog 5 axes · Streaming G-code</a:t>
             </a:r>
-            <a:endParaRPr lang="en-US" sz="1350" dirty="0"/>
+            <a:endParaRPr lang="en-US" sz="1300" dirty="0"/>
           </a:p>
           <a:p>
             <a:pPr indent="0" marL="0">
@@ -5099,7 +6414,7 @@
               <a:buNone/>
             </a:pPr>
             <a:r>
-              <a:rPr lang="en-US" sz="1350" dirty="0">
+              <a:rPr lang="en-US" sz="1300" dirty="0">
                 <a:solidFill>
                   <a:srgbClr val="EAECEF"/>
                 </a:solidFill>
@@ -5109,7 +6424,7 @@
               </a:rPr>
               <a:t>Visualiseur 3D Trunnion · Palpage · WCS</a:t>
             </a:r>
-            <a:endParaRPr lang="en-US" sz="1350" dirty="0"/>
+            <a:endParaRPr lang="en-US" sz="1300" dirty="0"/>
           </a:p>
           <a:p>
             <a:pPr indent="0" marL="0">
@@ -5119,7 +6434,7 @@
               <a:buNone/>
             </a:pPr>
             <a:r>
-              <a:rPr lang="en-US" sz="1350" dirty="0">
+              <a:rPr lang="en-US" sz="1300" dirty="0">
                 <a:solidFill>
                   <a:srgbClr val="EAECEF"/>
                 </a:solidFill>
@@ -5129,7 +6444,7 @@
               </a:rPr>
               <a:t>Sécurité matérielle (arrêt d'urgence, watchdog)</a:t>
             </a:r>
-            <a:endParaRPr lang="en-US" sz="1350" dirty="0"/>
+            <a:endParaRPr lang="en-US" sz="1300" dirty="0"/>
           </a:p>
         </p:txBody>
       </p:sp>
@@ -5235,7 +6550,7 @@
                 <a:ea typeface="Calibri" pitchFamily="34" charset="-122"/>
                 <a:cs typeface="Calibri" pitchFamily="34" charset="-120"/>
               </a:rPr>
-              <a:t> — l'opérateur parle, la machine exécute, en toute sécurité.</a:t>
+              <a:t> — l'opérateur parle, la machine exécute, sans risque de collision.</a:t>
             </a:r>
             <a:endParaRPr lang="en-US" sz="1800" dirty="0"/>
           </a:p>
@@ -5249,7 +6564,7 @@
         </p:nvSpPr>
         <p:spPr>
           <a:xfrm>
-            <a:off x="566928" y="6455664"/>
+            <a:off x="566928" y="6473952"/>
             <a:ext cx="11055096" cy="274320"/>
           </a:xfrm>
           <a:prstGeom prst="rect">
@@ -5262,7 +6577,7 @@
           <a:bodyPr wrap="square" lIns="0" tIns="0" rIns="0" bIns="0" rtlCol="0" anchor="ctr"/>
           <a:lstStyle/>
           <a:p>
-            <a:pPr algn="l" indent="0" marL="0">
+            <a:pPr indent="0" marL="0">
               <a:buNone/>
             </a:pPr>
             <a:r>
@@ -5581,7 +6896,7 @@
         </p:nvSpPr>
         <p:spPr>
           <a:xfrm>
-            <a:off x="566928" y="6455664"/>
+            <a:off x="566928" y="6473952"/>
             <a:ext cx="11055096" cy="274320"/>
           </a:xfrm>
           <a:prstGeom prst="rect">
@@ -5594,7 +6909,7 @@
           <a:bodyPr wrap="square" lIns="0" tIns="0" rIns="0" bIns="0" rtlCol="0" anchor="ctr"/>
           <a:lstStyle/>
           <a:p>
-            <a:pPr algn="l" indent="0" marL="0">
+            <a:pPr indent="0" marL="0">
               <a:buNone/>
             </a:pPr>
             <a:r>
@@ -5871,7 +7186,7 @@
                 <a:ea typeface="Calibri" pitchFamily="34" charset="-122"/>
                 <a:cs typeface="Calibri" pitchFamily="34" charset="-120"/>
               </a:rPr>
-              <a:t>LLM + function calling · 12 outils machine · permissions par outil · arrêt d'urgence prioritaire</a:t>
+              <a:t>LLM + function calling · 12 outils · permissions par outil · arrêt d'urgence prioritaire</a:t>
             </a:r>
             <a:endParaRPr lang="en-US" sz="1250" dirty="0"/>
           </a:p>
@@ -6022,7 +7337,7 @@
                 <a:ea typeface="Calibri" pitchFamily="34" charset="-122"/>
                 <a:cs typeface="Calibri" pitchFamily="34" charset="-120"/>
               </a:rPr>
-              <a:t>simule toute la trajectoire vs limites mécaniques réelles AVANT tout mouvement → zéro collision</a:t>
+              <a:t>simule toute la trajectoire vs limites réelles AVANT tout mouvement → zéro collision</a:t>
             </a:r>
             <a:endParaRPr lang="en-US" sz="1250" dirty="0"/>
           </a:p>
@@ -6131,7 +7446,7 @@
                 <a:ea typeface="Calibri" pitchFamily="34" charset="-122"/>
                 <a:cs typeface="Calibri" pitchFamily="34" charset="-120"/>
               </a:rPr>
-              <a:t>Résilience connectivité</a:t>
+              <a:t>Résilience &amp; coût</a:t>
             </a:r>
             <a:endParaRPr lang="en-US" sz="1600" dirty="0"/>
           </a:p>
@@ -6173,7 +7488,7 @@
                 <a:ea typeface="Calibri" pitchFamily="34" charset="-122"/>
                 <a:cs typeface="Calibri" pitchFamily="34" charset="-120"/>
               </a:rPr>
-              <a:t>appels IA routés en 4G/5G, téléphone sur le WiFi machine · repli multi-modèles (gratuit)</a:t>
+              <a:t>appels IA en 4G/5G · repli multi-modèles · 500 requêtes/jour gratuites</a:t>
             </a:r>
             <a:endParaRPr lang="en-US" sz="1250" dirty="0"/>
           </a:p>
@@ -6248,7 +7563,7 @@
                 <a:ea typeface="Calibri" pitchFamily="34" charset="-122"/>
                 <a:cs typeface="Calibri" pitchFamily="34" charset="-120"/>
               </a:rPr>
-              <a:t>Le hardware CNC est devenu quasi gratuit (FluidNC/ESP32), et le function-calling des LLM rend enfin le pilotage en langage naturel fiable. </a:t>
+              <a:t>Le hardware CNC est devenu quasi gratuit (FluidNC/ESP32) et le function-calling rend le pilotage en langage naturel fiable. </a:t>
             </a:r>
             <a:pPr indent="0" marL="0">
               <a:buNone/>
@@ -6262,7 +7577,7 @@
                 <a:ea typeface="Calibri" pitchFamily="34" charset="-122"/>
                 <a:cs typeface="Calibri" pitchFamily="34" charset="-120"/>
               </a:rPr>
-              <a:t>L'IP de Forgeron = la couche de contrôle sûr, pas le modèle.</a:t>
+              <a:t>Notre avantage = la couche de sécurité, pas le modèle.</a:t>
             </a:r>
             <a:endParaRPr lang="en-US" sz="1500" dirty="0"/>
           </a:p>
@@ -6276,7 +7591,7 @@
         </p:nvSpPr>
         <p:spPr>
           <a:xfrm>
-            <a:off x="566928" y="6455664"/>
+            <a:off x="566928" y="6473952"/>
             <a:ext cx="11055096" cy="274320"/>
           </a:xfrm>
           <a:prstGeom prst="rect">
@@ -6289,7 +7604,7 @@
           <a:bodyPr wrap="square" lIns="0" tIns="0" rIns="0" bIns="0" rtlCol="0" anchor="ctr"/>
           <a:lstStyle/>
           <a:p>
-            <a:pPr algn="l" indent="0" marL="0">
+            <a:pPr indent="0" marL="0">
               <a:buNone/>
             </a:pPr>
             <a:r>
@@ -6429,12 +7744,12 @@
         </p:nvSpPr>
         <p:spPr>
           <a:xfrm>
-            <a:off x="566928" y="1417320"/>
-            <a:ext cx="11055096" cy="1051560"/>
+            <a:off x="566928" y="1371600"/>
+            <a:ext cx="11055096" cy="914400"/>
           </a:xfrm>
           <a:prstGeom prst="roundRect">
             <a:avLst>
-              <a:gd name="adj" fmla="val 7826"/>
+              <a:gd name="adj" fmla="val 9000"/>
             </a:avLst>
           </a:prstGeom>
           <a:solidFill>
@@ -6456,8 +7771,8 @@
         </p:nvSpPr>
         <p:spPr>
           <a:xfrm>
-            <a:off x="749808" y="1581912"/>
-            <a:ext cx="1371600" cy="731520"/>
+            <a:off x="749808" y="1481328"/>
+            <a:ext cx="1371600" cy="694944"/>
           </a:xfrm>
           <a:prstGeom prst="rect">
             <a:avLst/>
@@ -6473,7 +7788,7 @@
               <a:buNone/>
             </a:pPr>
             <a:r>
-              <a:rPr lang="en-US" sz="2600" b="1" dirty="0">
+              <a:rPr lang="en-US" sz="2400" b="1" dirty="0">
                 <a:solidFill>
                   <a:srgbClr val="FF6A1A"/>
                 </a:solidFill>
@@ -6483,7 +7798,7 @@
               </a:rPr>
               <a:t>TAM</a:t>
             </a:r>
-            <a:endParaRPr lang="en-US" sz="2600" dirty="0"/>
+            <a:endParaRPr lang="en-US" sz="2400" dirty="0"/>
           </a:p>
         </p:txBody>
       </p:sp>
@@ -6495,8 +7810,8 @@
         </p:nvSpPr>
         <p:spPr>
           <a:xfrm>
-            <a:off x="2304288" y="1417320"/>
-            <a:ext cx="4572000" cy="1051560"/>
+            <a:off x="2304288" y="1371600"/>
+            <a:ext cx="4572000" cy="914400"/>
           </a:xfrm>
           <a:prstGeom prst="rect">
             <a:avLst/>
@@ -6534,8 +7849,8 @@
         </p:nvSpPr>
         <p:spPr>
           <a:xfrm>
-            <a:off x="6876288" y="1417320"/>
-            <a:ext cx="1828800" cy="1051560"/>
+            <a:off x="6876288" y="1371600"/>
+            <a:ext cx="1828800" cy="914400"/>
           </a:xfrm>
           <a:prstGeom prst="rect">
             <a:avLst/>
@@ -6573,8 +7888,8 @@
         </p:nvSpPr>
         <p:spPr>
           <a:xfrm>
-            <a:off x="8878824" y="1417320"/>
-            <a:ext cx="2560320" cy="1051560"/>
+            <a:off x="8878824" y="1371600"/>
+            <a:ext cx="2560320" cy="914400"/>
           </a:xfrm>
           <a:prstGeom prst="rect">
             <a:avLst/>
@@ -6627,12 +7942,12 @@
         </p:nvSpPr>
         <p:spPr>
           <a:xfrm>
-            <a:off x="566928" y="2587752"/>
-            <a:ext cx="11055096" cy="1051560"/>
+            <a:off x="566928" y="2395728"/>
+            <a:ext cx="11055096" cy="914400"/>
           </a:xfrm>
           <a:prstGeom prst="roundRect">
             <a:avLst>
-              <a:gd name="adj" fmla="val 7826"/>
+              <a:gd name="adj" fmla="val 9000"/>
             </a:avLst>
           </a:prstGeom>
           <a:solidFill>
@@ -6654,8 +7969,8 @@
         </p:nvSpPr>
         <p:spPr>
           <a:xfrm>
-            <a:off x="749808" y="2752344"/>
-            <a:ext cx="1371600" cy="731520"/>
+            <a:off x="749808" y="2505456"/>
+            <a:ext cx="1371600" cy="694944"/>
           </a:xfrm>
           <a:prstGeom prst="rect">
             <a:avLst/>
@@ -6671,7 +7986,7 @@
               <a:buNone/>
             </a:pPr>
             <a:r>
-              <a:rPr lang="en-US" sz="2600" b="1" dirty="0">
+              <a:rPr lang="en-US" sz="2400" b="1" dirty="0">
                 <a:solidFill>
                   <a:srgbClr val="FF8C42"/>
                 </a:solidFill>
@@ -6681,7 +7996,7 @@
               </a:rPr>
               <a:t>SAM</a:t>
             </a:r>
-            <a:endParaRPr lang="en-US" sz="2600" dirty="0"/>
+            <a:endParaRPr lang="en-US" sz="2400" dirty="0"/>
           </a:p>
         </p:txBody>
       </p:sp>
@@ -6693,8 +8008,8 @@
         </p:nvSpPr>
         <p:spPr>
           <a:xfrm>
-            <a:off x="2304288" y="2587752"/>
-            <a:ext cx="4572000" cy="1051560"/>
+            <a:off x="2304288" y="2395728"/>
+            <a:ext cx="4572000" cy="914400"/>
           </a:xfrm>
           <a:prstGeom prst="rect">
             <a:avLst/>
@@ -6732,8 +8047,8 @@
         </p:nvSpPr>
         <p:spPr>
           <a:xfrm>
-            <a:off x="6876288" y="2587752"/>
-            <a:ext cx="1828800" cy="1051560"/>
+            <a:off x="6876288" y="2395728"/>
+            <a:ext cx="1828800" cy="914400"/>
           </a:xfrm>
           <a:prstGeom prst="rect">
             <a:avLst/>
@@ -6771,8 +8086,8 @@
         </p:nvSpPr>
         <p:spPr>
           <a:xfrm>
-            <a:off x="8878824" y="2587752"/>
-            <a:ext cx="2560320" cy="1051560"/>
+            <a:off x="8878824" y="2395728"/>
+            <a:ext cx="2560320" cy="914400"/>
           </a:xfrm>
           <a:prstGeom prst="rect">
             <a:avLst/>
@@ -6825,12 +8140,12 @@
         </p:nvSpPr>
         <p:spPr>
           <a:xfrm>
-            <a:off x="566928" y="3758184"/>
-            <a:ext cx="11055096" cy="1051560"/>
+            <a:off x="566928" y="3419856"/>
+            <a:ext cx="11055096" cy="914400"/>
           </a:xfrm>
           <a:prstGeom prst="roundRect">
             <a:avLst>
-              <a:gd name="adj" fmla="val 7826"/>
+              <a:gd name="adj" fmla="val 9000"/>
             </a:avLst>
           </a:prstGeom>
           <a:solidFill>
@@ -6852,8 +8167,8 @@
         </p:nvSpPr>
         <p:spPr>
           <a:xfrm>
-            <a:off x="749808" y="3922776"/>
-            <a:ext cx="1371600" cy="731520"/>
+            <a:off x="749808" y="3529584"/>
+            <a:ext cx="1371600" cy="694944"/>
           </a:xfrm>
           <a:prstGeom prst="rect">
             <a:avLst/>
@@ -6869,7 +8184,7 @@
               <a:buNone/>
             </a:pPr>
             <a:r>
-              <a:rPr lang="en-US" sz="2600" b="1" dirty="0">
+              <a:rPr lang="en-US" sz="2400" b="1" dirty="0">
                 <a:solidFill>
                   <a:srgbClr val="FFB347"/>
                 </a:solidFill>
@@ -6879,7 +8194,7 @@
               </a:rPr>
               <a:t>SOM</a:t>
             </a:r>
-            <a:endParaRPr lang="en-US" sz="2600" dirty="0"/>
+            <a:endParaRPr lang="en-US" sz="2400" dirty="0"/>
           </a:p>
         </p:txBody>
       </p:sp>
@@ -6891,8 +8206,8 @@
         </p:nvSpPr>
         <p:spPr>
           <a:xfrm>
-            <a:off x="2304288" y="3758184"/>
-            <a:ext cx="4572000" cy="1051560"/>
+            <a:off x="2304288" y="3419856"/>
+            <a:ext cx="4572000" cy="914400"/>
           </a:xfrm>
           <a:prstGeom prst="rect">
             <a:avLst/>
@@ -6930,8 +8245,8 @@
         </p:nvSpPr>
         <p:spPr>
           <a:xfrm>
-            <a:off x="6876288" y="3758184"/>
-            <a:ext cx="1828800" cy="1051560"/>
+            <a:off x="6876288" y="3419856"/>
+            <a:ext cx="1828800" cy="914400"/>
           </a:xfrm>
           <a:prstGeom prst="rect">
             <a:avLst/>
@@ -6969,8 +8284,8 @@
         </p:nvSpPr>
         <p:spPr>
           <a:xfrm>
-            <a:off x="8878824" y="3758184"/>
-            <a:ext cx="2560320" cy="1051560"/>
+            <a:off x="8878824" y="3419856"/>
+            <a:ext cx="2560320" cy="914400"/>
           </a:xfrm>
           <a:prstGeom prst="rect">
             <a:avLst/>
@@ -7017,14 +8332,36 @@
       </p:sp>
       <p:sp>
         <p:nvSpPr>
-          <p:cNvPr id="19" name="Text 17"/>
-          <p:cNvSpPr txBox="1"/>
-          <p:nvPr/>
-        </p:nvSpPr>
-        <p:spPr>
-          <a:xfrm>
-            <a:off x="566928" y="5074920"/>
-            <a:ext cx="11055096" cy="548640"/>
+          <p:cNvPr id="19" name="Shape 17"/>
+          <p:cNvSpPr/>
+          <p:nvPr/>
+        </p:nvSpPr>
+        <p:spPr>
+          <a:xfrm>
+            <a:off x="566928" y="4480560"/>
+            <a:ext cx="11055096" cy="960120"/>
+          </a:xfrm>
+          <a:prstGeom prst="roundRect">
+            <a:avLst>
+              <a:gd name="adj" fmla="val 9524"/>
+            </a:avLst>
+          </a:prstGeom>
+          <a:solidFill>
+            <a:srgbClr val="2B3644"/>
+          </a:solidFill>
+          <a:ln/>
+        </p:spPr>
+      </p:sp>
+      <p:sp>
+        <p:nvSpPr>
+          <p:cNvPr id="20" name="Text 18"/>
+          <p:cNvSpPr txBox="1"/>
+          <p:nvPr/>
+        </p:nvSpPr>
+        <p:spPr>
+          <a:xfrm>
+            <a:off x="886968" y="4480560"/>
+            <a:ext cx="10415016" cy="960120"/>
           </a:xfrm>
           <a:prstGeom prst="rect">
             <a:avLst/>
@@ -7040,7 +8377,74 @@
               <a:buNone/>
             </a:pPr>
             <a:r>
-              <a:rPr lang="en-US" sz="1100" i="1" dirty="0">
+              <a:rPr lang="en-US" sz="1500" dirty="0">
+                <a:solidFill>
+                  <a:srgbClr val="EAECEF"/>
+                </a:solidFill>
+                <a:latin typeface="Calibri" pitchFamily="34" charset="0"/>
+                <a:ea typeface="Calibri" pitchFamily="34" charset="-122"/>
+                <a:cs typeface="Calibri" pitchFamily="34" charset="-120"/>
+              </a:rPr>
+              <a:t>Part actuellement servie par une solution locale abordable : </a:t>
+            </a:r>
+            <a:pPr indent="0" marL="0">
+              <a:buNone/>
+            </a:pPr>
+            <a:r>
+              <a:rPr lang="en-US" sz="1800" b="1" dirty="0">
+                <a:solidFill>
+                  <a:srgbClr val="1EBE7B"/>
+                </a:solidFill>
+                <a:latin typeface="Calibri" pitchFamily="34" charset="0"/>
+                <a:ea typeface="Calibri" pitchFamily="34" charset="-122"/>
+                <a:cs typeface="Calibri" pitchFamily="34" charset="-120"/>
+              </a:rPr>
+              <a:t>≈ 0 %</a:t>
+            </a:r>
+            <a:pPr indent="0" marL="0">
+              <a:buNone/>
+            </a:pPr>
+            <a:r>
+              <a:rPr lang="en-US" sz="1500" dirty="0">
+                <a:solidFill>
+                  <a:srgbClr val="EAECEF"/>
+                </a:solidFill>
+                <a:latin typeface="Calibri" pitchFamily="34" charset="0"/>
+                <a:ea typeface="Calibri" pitchFamily="34" charset="-122"/>
+                <a:cs typeface="Calibri" pitchFamily="34" charset="-120"/>
+              </a:rPr>
+              <a:t>  — le marché est capté par des contrôleurs importés, chers et fermés.</a:t>
+            </a:r>
+            <a:endParaRPr lang="en-US" sz="1500" dirty="0"/>
+          </a:p>
+        </p:txBody>
+      </p:sp>
+      <p:sp>
+        <p:nvSpPr>
+          <p:cNvPr id="21" name="Text 19"/>
+          <p:cNvSpPr txBox="1"/>
+          <p:nvPr/>
+        </p:nvSpPr>
+        <p:spPr>
+          <a:xfrm>
+            <a:off x="566928" y="5532120"/>
+            <a:ext cx="11055096" cy="365760"/>
+          </a:xfrm>
+          <a:prstGeom prst="rect">
+            <a:avLst/>
+          </a:prstGeom>
+          <a:noFill/>
+          <a:ln/>
+        </p:spPr>
+        <p:txBody>
+          <a:bodyPr wrap="square" lIns="0" tIns="0" rIns="0" bIns="0" rtlCol="0" anchor="ctr"/>
+          <a:lstStyle/>
+          <a:p>
+            <a:pPr indent="0" marL="0">
+              <a:buNone/>
+            </a:pPr>
+            <a:r>
+              <a:rPr lang="en-US" sz="1000" i="1" dirty="0">
                 <a:solidFill>
                   <a:srgbClr val="6E7A88"/>
                 </a:solidFill>
@@ -7048,21 +8452,21 @@
                 <a:ea typeface="Calibri" pitchFamily="34" charset="-122"/>
                 <a:cs typeface="Calibri" pitchFamily="34" charset="-120"/>
               </a:rPr>
-              <a:t>Estimations à valider (customer discovery / parcours Wadhwani). Hypothèse : revenu moyen ≈ 100 000 FCFA / client / an (abonnement Pro + hardware amorti).</a:t>
-            </a:r>
-            <a:endParaRPr lang="en-US" sz="1100" dirty="0"/>
-          </a:p>
-        </p:txBody>
-      </p:sp>
-      <p:sp>
-        <p:nvSpPr>
-          <p:cNvPr id="20" name="Text 18"/>
-          <p:cNvSpPr txBox="1"/>
-          <p:nvPr/>
-        </p:nvSpPr>
-        <p:spPr>
-          <a:xfrm>
-            <a:off x="566928" y="6455664"/>
+              <a:t>Estimations à valider (customer discovery / Wadhwani) · hypothèse revenu ≈ 100 000 FCFA / client / an (Pro + hardware amorti).</a:t>
+            </a:r>
+            <a:endParaRPr lang="en-US" sz="1000" dirty="0"/>
+          </a:p>
+        </p:txBody>
+      </p:sp>
+      <p:sp>
+        <p:nvSpPr>
+          <p:cNvPr id="22" name="Text 20"/>
+          <p:cNvSpPr txBox="1"/>
+          <p:nvPr/>
+        </p:nvSpPr>
+        <p:spPr>
+          <a:xfrm>
+            <a:off x="566928" y="6473952"/>
             <a:ext cx="11055096" cy="274320"/>
           </a:xfrm>
           <a:prstGeom prst="rect">
@@ -7075,7 +8479,7 @@
           <a:bodyPr wrap="square" lIns="0" tIns="0" rIns="0" bIns="0" rtlCol="0" anchor="ctr"/>
           <a:lstStyle/>
           <a:p>
-            <a:pPr algn="l" indent="0" marL="0">
+            <a:pPr indent="0" marL="0">
               <a:buNone/>
             </a:pPr>
             <a:r>
@@ -7216,7 +8620,7 @@
         <p:spPr>
           <a:xfrm>
             <a:off x="566928" y="1554480"/>
-            <a:ext cx="2558034" cy="2743200"/>
+            <a:ext cx="2558034" cy="2651760"/>
           </a:xfrm>
           <a:prstGeom prst="roundRect">
             <a:avLst>
@@ -7286,7 +8690,7 @@
         <p:spPr>
           <a:xfrm>
             <a:off x="704088" y="2514600"/>
-            <a:ext cx="2283714" cy="640080"/>
+            <a:ext cx="2283714" cy="548640"/>
           </a:xfrm>
           <a:prstGeom prst="rect">
             <a:avLst/>
@@ -7324,8 +8728,8 @@
         </p:nvSpPr>
         <p:spPr>
           <a:xfrm>
-            <a:off x="749808" y="3108960"/>
-            <a:ext cx="2192274" cy="1097280"/>
+            <a:off x="749808" y="3063240"/>
+            <a:ext cx="2192274" cy="1051560"/>
           </a:xfrm>
           <a:prstGeom prst="rect">
             <a:avLst/>
@@ -7352,7 +8756,7 @@
                 <a:ea typeface="Calibri" pitchFamily="34" charset="-122"/>
                 <a:cs typeface="Calibri" pitchFamily="34" charset="-120"/>
               </a:rPr>
-              <a:t>Contrôle de base gratuit → adoption virale dans les fablabs</a:t>
+              <a:t>Contrôle de base gratuit → adoption dans les fablabs</a:t>
             </a:r>
             <a:endParaRPr lang="en-US" sz="1200" dirty="0"/>
           </a:p>
@@ -7366,7 +8770,7 @@
         </p:nvSpPr>
         <p:spPr>
           <a:xfrm>
-            <a:off x="3106674" y="2651760"/>
+            <a:off x="3106674" y="2606040"/>
             <a:ext cx="292608" cy="365760"/>
           </a:xfrm>
           <a:prstGeom prst="rect">
@@ -7406,7 +8810,7 @@
         <p:spPr>
           <a:xfrm>
             <a:off x="3399282" y="1554480"/>
-            <a:ext cx="2558034" cy="2743200"/>
+            <a:ext cx="2558034" cy="2651760"/>
           </a:xfrm>
           <a:prstGeom prst="roundRect">
             <a:avLst>
@@ -7476,7 +8880,7 @@
         <p:spPr>
           <a:xfrm>
             <a:off x="3536442" y="2514600"/>
-            <a:ext cx="2283714" cy="640080"/>
+            <a:ext cx="2283714" cy="548640"/>
           </a:xfrm>
           <a:prstGeom prst="rect">
             <a:avLst/>
@@ -7514,8 +8918,8 @@
         </p:nvSpPr>
         <p:spPr>
           <a:xfrm>
-            <a:off x="3582162" y="3108960"/>
-            <a:ext cx="2192274" cy="1097280"/>
+            <a:off x="3582162" y="3063240"/>
+            <a:ext cx="2192274" cy="1051560"/>
           </a:xfrm>
           <a:prstGeom prst="rect">
             <a:avLst/>
@@ -7542,7 +8946,7 @@
                 <a:ea typeface="Calibri" pitchFamily="34" charset="-122"/>
                 <a:cs typeface="Calibri" pitchFamily="34" charset="-120"/>
               </a:rPr>
-              <a:t>Agent IA, multi-machines, analytics avancés</a:t>
+              <a:t>Agent IA, multi-machines, analytics</a:t>
             </a:r>
             <a:endParaRPr lang="en-US" sz="1200" dirty="0"/>
           </a:p>
@@ -7556,7 +8960,7 @@
         </p:nvSpPr>
         <p:spPr>
           <a:xfrm>
-            <a:off x="5939028" y="2651760"/>
+            <a:off x="5939028" y="2606040"/>
             <a:ext cx="292608" cy="365760"/>
           </a:xfrm>
           <a:prstGeom prst="rect">
@@ -7596,7 +9000,7 @@
         <p:spPr>
           <a:xfrm>
             <a:off x="6231636" y="1554480"/>
-            <a:ext cx="2558034" cy="2743200"/>
+            <a:ext cx="2558034" cy="2651760"/>
           </a:xfrm>
           <a:prstGeom prst="roundRect">
             <a:avLst>
@@ -7666,7 +9070,7 @@
         <p:spPr>
           <a:xfrm>
             <a:off x="6368796" y="2514600"/>
-            <a:ext cx="2283714" cy="640080"/>
+            <a:ext cx="2283714" cy="548640"/>
           </a:xfrm>
           <a:prstGeom prst="rect">
             <a:avLst/>
@@ -7704,8 +9108,8 @@
         </p:nvSpPr>
         <p:spPr>
           <a:xfrm>
-            <a:off x="6414516" y="3108960"/>
-            <a:ext cx="2192274" cy="1097280"/>
+            <a:off x="6414516" y="3063240"/>
+            <a:ext cx="2192274" cy="1051560"/>
           </a:xfrm>
           <a:prstGeom prst="rect">
             <a:avLst/>
@@ -7732,7 +9136,7 @@
                 <a:ea typeface="Calibri" pitchFamily="34" charset="-122"/>
                 <a:cs typeface="Calibri" pitchFamily="34" charset="-120"/>
               </a:rPr>
-              <a:t>ESP32 + drivers pré-flashés et calibrés (certifiés)</a:t>
+              <a:t>ESP32 + drivers pré-flashés &amp; calibrés</a:t>
             </a:r>
             <a:endParaRPr lang="en-US" sz="1200" dirty="0"/>
           </a:p>
@@ -7746,7 +9150,7 @@
         </p:nvSpPr>
         <p:spPr>
           <a:xfrm>
-            <a:off x="8771382" y="2651760"/>
+            <a:off x="8771382" y="2606040"/>
             <a:ext cx="292608" cy="365760"/>
           </a:xfrm>
           <a:prstGeom prst="rect">
@@ -7786,7 +9190,7 @@
         <p:spPr>
           <a:xfrm>
             <a:off x="9063990" y="1554480"/>
-            <a:ext cx="2558034" cy="2743200"/>
+            <a:ext cx="2558034" cy="2651760"/>
           </a:xfrm>
           <a:prstGeom prst="roundRect">
             <a:avLst>
@@ -7856,7 +9260,7 @@
         <p:spPr>
           <a:xfrm>
             <a:off x="9201150" y="2514600"/>
-            <a:ext cx="2283714" cy="640080"/>
+            <a:ext cx="2283714" cy="548640"/>
           </a:xfrm>
           <a:prstGeom prst="rect">
             <a:avLst/>
@@ -7894,8 +9298,8 @@
         </p:nvSpPr>
         <p:spPr>
           <a:xfrm>
-            <a:off x="9246870" y="3108960"/>
-            <a:ext cx="2192274" cy="1097280"/>
+            <a:off x="9246870" y="3063240"/>
+            <a:ext cx="2192274" cy="1051560"/>
           </a:xfrm>
           <a:prstGeom prst="rect">
             <a:avLst/>
@@ -7930,14 +9334,36 @@
       </p:sp>
       <p:sp>
         <p:nvSpPr>
-          <p:cNvPr id="23" name="Text 21"/>
-          <p:cNvSpPr txBox="1"/>
-          <p:nvPr/>
-        </p:nvSpPr>
-        <p:spPr>
-          <a:xfrm>
-            <a:off x="566928" y="4754880"/>
-            <a:ext cx="11055096" cy="640080"/>
+          <p:cNvPr id="23" name="Shape 21"/>
+          <p:cNvSpPr/>
+          <p:nvPr/>
+        </p:nvSpPr>
+        <p:spPr>
+          <a:xfrm>
+            <a:off x="566928" y="4434840"/>
+            <a:ext cx="11055096" cy="960120"/>
+          </a:xfrm>
+          <a:prstGeom prst="roundRect">
+            <a:avLst>
+              <a:gd name="adj" fmla="val 9524"/>
+            </a:avLst>
+          </a:prstGeom>
+          <a:solidFill>
+            <a:srgbClr val="2B3644"/>
+          </a:solidFill>
+          <a:ln/>
+        </p:spPr>
+      </p:sp>
+      <p:sp>
+        <p:nvSpPr>
+          <p:cNvPr id="24" name="Text 22"/>
+          <p:cNvSpPr txBox="1"/>
+          <p:nvPr/>
+        </p:nvSpPr>
+        <p:spPr>
+          <a:xfrm>
+            <a:off x="886968" y="4434840"/>
+            <a:ext cx="10415016" cy="960120"/>
           </a:xfrm>
           <a:prstGeom prst="rect">
             <a:avLst/>
@@ -7949,11 +9375,11 @@
           <a:bodyPr wrap="square" lIns="0" tIns="0" rIns="0" bIns="0" rtlCol="0" anchor="ctr"/>
           <a:lstStyle/>
           <a:p>
-            <a:pPr algn="ctr" indent="0" marL="0">
-              <a:buNone/>
-            </a:pPr>
-            <a:r>
-              <a:rPr lang="en-US" sz="1400" dirty="0">
+            <a:pPr indent="0" marL="0">
+              <a:buNone/>
+            </a:pPr>
+            <a:r>
+              <a:rPr lang="en-US" sz="1450" dirty="0">
                 <a:solidFill>
                   <a:srgbClr val="EAECEF"/>
                 </a:solidFill>
@@ -7961,21 +9387,49 @@
                 <a:ea typeface="Calibri" pitchFamily="34" charset="-122"/>
                 <a:cs typeface="Calibri" pitchFamily="34" charset="-120"/>
               </a:rPr>
-              <a:t>De l'adoption gratuite au revenu récurrent, avec le hardware comme accélérateur — un modèle à faible coût d'entrée pour les ateliers africains.</a:t>
-            </a:r>
-            <a:endParaRPr lang="en-US" sz="1400" dirty="0"/>
-          </a:p>
-        </p:txBody>
-      </p:sp>
-      <p:sp>
-        <p:nvSpPr>
-          <p:cNvPr id="24" name="Text 22"/>
-          <p:cNvSpPr txBox="1"/>
-          <p:nvPr/>
-        </p:nvSpPr>
-        <p:spPr>
-          <a:xfrm>
-            <a:off x="566928" y="6455664"/>
+              <a:t>Revenu moyen visé ≈ </a:t>
+            </a:r>
+            <a:pPr indent="0" marL="0">
+              <a:buNone/>
+            </a:pPr>
+            <a:r>
+              <a:rPr lang="en-US" sz="1450" b="1" dirty="0">
+                <a:solidFill>
+                  <a:srgbClr val="FFFFFF"/>
+                </a:solidFill>
+                <a:latin typeface="Calibri" pitchFamily="34" charset="0"/>
+                <a:ea typeface="Calibri" pitchFamily="34" charset="-122"/>
+                <a:cs typeface="Calibri" pitchFamily="34" charset="-120"/>
+              </a:rPr>
+              <a:t>100 000 FCFA / client / an</a:t>
+            </a:r>
+            <a:pPr indent="0" marL="0">
+              <a:buNone/>
+            </a:pPr>
+            <a:r>
+              <a:rPr lang="en-US" sz="1450" dirty="0">
+                <a:solidFill>
+                  <a:srgbClr val="EAECEF"/>
+                </a:solidFill>
+                <a:latin typeface="Calibri" pitchFamily="34" charset="0"/>
+                <a:ea typeface="Calibri" pitchFamily="34" charset="-122"/>
+                <a:cs typeface="Calibri" pitchFamily="34" charset="-120"/>
+              </a:rPr>
+              <a:t>  ·  faible coût d'entrée, revenu récurrent, hardware comme accélérateur.</a:t>
+            </a:r>
+            <a:endParaRPr lang="en-US" sz="1450" dirty="0"/>
+          </a:p>
+        </p:txBody>
+      </p:sp>
+      <p:sp>
+        <p:nvSpPr>
+          <p:cNvPr id="25" name="Text 23"/>
+          <p:cNvSpPr txBox="1"/>
+          <p:nvPr/>
+        </p:nvSpPr>
+        <p:spPr>
+          <a:xfrm>
+            <a:off x="566928" y="6473952"/>
             <a:ext cx="11055096" cy="274320"/>
           </a:xfrm>
           <a:prstGeom prst="rect">
@@ -7988,7 +9442,7 @@
           <a:bodyPr wrap="square" lIns="0" tIns="0" rIns="0" bIns="0" rtlCol="0" anchor="ctr"/>
           <a:lstStyle/>
           <a:p>
-            <a:pPr algn="l" indent="0" marL="0">
+            <a:pPr indent="0" marL="0">
               <a:buNone/>
             </a:pPr>
             <a:r>
@@ -8129,11 +9583,11 @@
         <p:spPr>
           <a:xfrm>
             <a:off x="566928" y="1417320"/>
-            <a:ext cx="5394960" cy="3840480"/>
+            <a:ext cx="5394960" cy="3931920"/>
           </a:xfrm>
           <a:prstGeom prst="roundRect">
             <a:avLst>
-              <a:gd name="adj" fmla="val 2143"/>
+              <a:gd name="adj" fmla="val 2093"/>
             </a:avLst>
           </a:prstGeom>
           <a:solidFill>
@@ -8194,8 +9648,8 @@
         </p:nvSpPr>
         <p:spPr>
           <a:xfrm>
-            <a:off x="886968" y="2057400"/>
-            <a:ext cx="4846320" cy="3017520"/>
+            <a:off x="886968" y="2103120"/>
+            <a:ext cx="4846320" cy="3108960"/>
           </a:xfrm>
           <a:prstGeom prst="rect">
             <a:avLst/>
@@ -8301,11 +9755,11 @@
         <p:spPr>
           <a:xfrm>
             <a:off x="6309360" y="1417320"/>
-            <a:ext cx="5312664" cy="3840480"/>
+            <a:ext cx="5312664" cy="3931920"/>
           </a:xfrm>
           <a:prstGeom prst="roundRect">
             <a:avLst>
-              <a:gd name="adj" fmla="val 2143"/>
+              <a:gd name="adj" fmla="val 2093"/>
             </a:avLst>
           </a:prstGeom>
           <a:solidFill>
@@ -8366,8 +9820,8 @@
         </p:nvSpPr>
         <p:spPr>
           <a:xfrm>
-            <a:off x="6583680" y="2057400"/>
-            <a:ext cx="4855464" cy="3017520"/>
+            <a:off x="6583680" y="2103120"/>
+            <a:ext cx="4855464" cy="3108960"/>
           </a:xfrm>
           <a:prstGeom prst="rect">
             <a:avLst/>
@@ -8458,7 +9912,7 @@
                 <a:ea typeface="Calibri" pitchFamily="34" charset="-122"/>
                 <a:cs typeface="Calibri" pitchFamily="34" charset="-120"/>
               </a:rPr>
-              <a:t>Phasage : Mali → Afrique de l'Ouest francophone → continent</a:t>
+              <a:t>Mali → Afrique de l'Ouest francophone → continent</a:t>
             </a:r>
             <a:endParaRPr lang="en-US" sz="1450" dirty="0"/>
           </a:p>
@@ -8472,7 +9926,7 @@
         </p:nvSpPr>
         <p:spPr>
           <a:xfrm>
-            <a:off x="566928" y="6455664"/>
+            <a:off x="566928" y="6473952"/>
             <a:ext cx="11055096" cy="274320"/>
           </a:xfrm>
           <a:prstGeom prst="rect">
@@ -8485,7 +9939,7 @@
           <a:bodyPr wrap="square" lIns="0" tIns="0" rIns="0" bIns="0" rtlCol="0" anchor="ctr"/>
           <a:lstStyle/>
           <a:p>
-            <a:pPr algn="l" indent="0" marL="0">
+            <a:pPr indent="0" marL="0">
               <a:buNone/>
             </a:pPr>
             <a:r>
@@ -10357,7 +11811,7 @@
         </p:nvSpPr>
         <p:spPr>
           <a:xfrm>
-            <a:off x="566928" y="6455664"/>
+            <a:off x="566928" y="6473952"/>
             <a:ext cx="11055096" cy="274320"/>
           </a:xfrm>
           <a:prstGeom prst="rect">
@@ -10370,7 +11824,7 @@
           <a:bodyPr wrap="square" lIns="0" tIns="0" rIns="0" bIns="0" rtlCol="0" anchor="ctr"/>
           <a:lstStyle/>
           <a:p>
-            <a:pPr algn="l" indent="0" marL="0">
+            <a:pPr indent="0" marL="0">
               <a:buNone/>
             </a:pPr>
             <a:r>

</xml_diff>